<commit_message>
Ship Firebase preview, secure accounts, polished UI and narrated submission
</commit_message>
<xml_diff>
--- a/artifacts/submission/Unpause-pitch-final.pptx
+++ b/artifacts/submission/Unpause-pitch-final.pptx
@@ -2,19 +2,19 @@
 <file path=ppt/presentation.xml><?xml version="1.0" encoding="utf-8"?>
 <p:presentation xmlns:p="http://schemas.openxmlformats.org/presentationml/2006/main">
   <p:sldMasterIdLst>
-    <p:sldMasterId xmlns:r="http://schemas.openxmlformats.org/officeDocument/2006/relationships" id="2147483648" r:id="Rcb43b286447b470b"/>
+    <p:sldMasterId xmlns:r="http://schemas.openxmlformats.org/officeDocument/2006/relationships" id="2147483648" r:id="R3402d1789b944f4e"/>
   </p:sldMasterIdLst>
   <p:notesMasterIdLst>
-    <p:notesMasterId xmlns:r="http://schemas.openxmlformats.org/officeDocument/2006/relationships" r:id="Rfba9dab9859a4f30"/>
+    <p:notesMasterId xmlns:r="http://schemas.openxmlformats.org/officeDocument/2006/relationships" r:id="Raaa602c0cb294047"/>
   </p:notesMasterIdLst>
   <p:sldIdLst>
-    <p:sldId xmlns:r="http://schemas.openxmlformats.org/officeDocument/2006/relationships" id="256" r:id="R0a1abcf419684efe"/>
-    <p:sldId xmlns:r="http://schemas.openxmlformats.org/officeDocument/2006/relationships" id="257" r:id="R1be21f6c24be4e62"/>
-    <p:sldId xmlns:r="http://schemas.openxmlformats.org/officeDocument/2006/relationships" id="258" r:id="R6f3abae092e046f5"/>
-    <p:sldId xmlns:r="http://schemas.openxmlformats.org/officeDocument/2006/relationships" id="259" r:id="R1bb587289ba7467a"/>
-    <p:sldId xmlns:r="http://schemas.openxmlformats.org/officeDocument/2006/relationships" id="260" r:id="Ra052f133c7724f32"/>
-    <p:sldId xmlns:r="http://schemas.openxmlformats.org/officeDocument/2006/relationships" id="261" r:id="R77f97e2c4ba04a56"/>
-    <p:sldId xmlns:r="http://schemas.openxmlformats.org/officeDocument/2006/relationships" id="262" r:id="Reb75ceed98364ab7"/>
+    <p:sldId xmlns:r="http://schemas.openxmlformats.org/officeDocument/2006/relationships" id="256" r:id="R48ee015254024529"/>
+    <p:sldId xmlns:r="http://schemas.openxmlformats.org/officeDocument/2006/relationships" id="257" r:id="R030e4e5d3b1f423b"/>
+    <p:sldId xmlns:r="http://schemas.openxmlformats.org/officeDocument/2006/relationships" id="258" r:id="Rec804b5535eb4c04"/>
+    <p:sldId xmlns:r="http://schemas.openxmlformats.org/officeDocument/2006/relationships" id="259" r:id="Raf0db12258e24d0c"/>
+    <p:sldId xmlns:r="http://schemas.openxmlformats.org/officeDocument/2006/relationships" id="260" r:id="Re9d709973cba4308"/>
+    <p:sldId xmlns:r="http://schemas.openxmlformats.org/officeDocument/2006/relationships" id="261" r:id="Rb62e4af325d04851"/>
+    <p:sldId xmlns:r="http://schemas.openxmlformats.org/officeDocument/2006/relationships" id="262" r:id="R2d0aa37404314630"/>
   </p:sldIdLst>
   <p:sldSz cx="12192000" cy="6858000"/>
   <p:notesSz cx="6858000" cy="9144000"/>
@@ -448,7 +448,7 @@
           <a:lstStyle xmlns:a="http://schemas.openxmlformats.org/drawingml/2006/main"/>
           <a:p xmlns:a="http://schemas.openxmlformats.org/drawingml/2006/main">
             <a:r>
-              <a:t>Unpause pitch. Creator: Shivam Gupta. Product and pricing hypothesis, September 2026. This deck does not claim a public release, customer traction, or verified paid conversion.</a:t>
+              <a:t>Unpause pitch. Creator: Shivam Gupta. Product and pricing hypothesis, September 2026. Live web app: https://unpause-studio.web.app . Public Android emulator demo: https://www.youtube.com/watch?v=jXpOlvDShRY . No qualifying public store release, customer traction, or verified paid conversion is claimed.</a:t>
             </a:r>
           </a:p>
         </p:txBody>
@@ -658,7 +658,7 @@
           <a:lstStyle xmlns:a="http://schemas.openxmlformats.org/drawingml/2006/main"/>
           <a:p xmlns:a="http://schemas.openxmlformats.org/drawingml/2006/main">
             <a:r>
-              <a:t>Product mechanics: suggestProjects filters by next-step duration and energy, excludes finished projects, and ranks blockers after ready work. Checkpoint history stores context and cumulative session minutes. UI implementation and final device behavior require release verification.</a:t>
+              <a:t>Product mechanics: suggestProjects filters by next-step duration and energy, excludes finished projects, and ranks blockers after ready work. Checkpoint history stores context and cumulative session minutes. The core browser and native emulator loop is verified. Current automated checks: 101 unit tests and 30 desktop/mobile browser scenarios. Final physical-device behavior remains a release check.</a:t>
             </a:r>
           </a:p>
         </p:txBody>
@@ -868,7 +868,7 @@
           <a:lstStyle xmlns:a="http://schemas.openxmlformats.org/drawingml/2006/main"/>
           <a:p xmlns:a="http://schemas.openxmlformats.org/drawingml/2006/main">
             <a:r>
-              <a:t>Status snapshot September 16, 2026. Source/integration claims refer to repository implementation, not public availability or passed store certification. Optional Supabase identity does not synchronize projects. No customer traction claimed. Galaxy publication requires real account approval, physical-device billing test, and public store release. Official event rules: https://revenuecat-shipaton-2026.devpost.com/rules . Release gates documented in docs/release/launch-checklist.md.</a:t>
+              <a:t>Status snapshot September 16, 2026. The public web app is live at https://unpause-studio.web.app . Public narrated Android emulator demo: https://www.youtube.com/watch?v=jXpOlvDShRY . Real hosted Firebase signup, reload persistence, sign-out, sign-in, account deletion, and rejection after deletion passed. Local projects survive account deletion. Firebase is primary, with Supabase a configurable fallback. Accounts do not synchronize projects. 101 unit tests and 30 browser scenarios pass. Android preview exists. iOS source and bundle configuration are prepared but no compiled iOS binary is claimed. Native physical-device auth persistence and password-reset email delivery still need acceptance evidence. No customer traction claimed. Galaxy publication requires real account approval, physical-device billing test, purchase-profile deletion backend, and public store release. Official event rules: https://revenuecat-shipaton-2026.devpost.com/rules . Release gates documented in docs/release/launch-checklist.md.</a:t>
             </a:r>
           </a:p>
         </p:txBody>
@@ -936,7 +936,7 @@
   </p:cSld>
   <p:clrMap bg1="lt1" tx1="dk1" bg2="lt2" tx2="dk2" accent1="accent1" accent2="accent2" accent3="accent3" accent4="accent4" accent5="accent5" accent6="accent6" hlink="hlink" folHlink="folHlink"/>
   <p:sldLayoutIdLst>
-    <p:sldLayoutId xmlns:r="http://schemas.openxmlformats.org/officeDocument/2006/relationships" id="2147483649" r:id="R8d728c577cac439e"/>
+    <p:sldLayoutId xmlns:r="http://schemas.openxmlformats.org/officeDocument/2006/relationships" id="2147483649" r:id="Re73cbdbb10974a3d"/>
   </p:sldLayoutIdLst>
   <p:txStyles>
     <p:titleStyle>
@@ -1487,7 +1487,7 @@
           <p:cNvPr id="10" name="">
             <a:extLst xmlns:a="http://schemas.openxmlformats.org/drawingml/2006/main">
               <a:ext uri="{FF2B5EF4-FFF2-40B4-BE49-F238E27FC236}">
-                <a16:creationId xmlns:a16="http://schemas.microsoft.com/office/drawing/2014/main" id="{0E4F8D73-C5F2-4EC4-98BF-B2699F3A9B6A}"/>
+                <a16:creationId xmlns:a16="http://schemas.microsoft.com/office/drawing/2014/main" id="{C982C179-3A1F-4509-A793-EB4AA9514749}"/>
               </a:ext>
             </a:extLst>
           </p:cNvPr>
@@ -1544,7 +1544,7 @@
           <p:cNvPr id="2" name="">
             <a:extLst xmlns:a="http://schemas.openxmlformats.org/drawingml/2006/main">
               <a:ext uri="{FF2B5EF4-FFF2-40B4-BE49-F238E27FC236}">
-                <a16:creationId xmlns:a16="http://schemas.microsoft.com/office/drawing/2014/main" id="{8D5412D9-501C-45FF-BD4E-D43A0F9C1EC8}"/>
+                <a16:creationId xmlns:a16="http://schemas.microsoft.com/office/drawing/2014/main" id="{F4EC87CC-4B63-4C12-8338-F8342D8B7963}"/>
               </a:ext>
             </a:extLst>
           </p:cNvPr>
@@ -1601,7 +1601,7 @@
           <p:cNvPr id="3" name="">
             <a:extLst xmlns:a="http://schemas.openxmlformats.org/drawingml/2006/main">
               <a:ext uri="{FF2B5EF4-FFF2-40B4-BE49-F238E27FC236}">
-                <a16:creationId xmlns:a16="http://schemas.microsoft.com/office/drawing/2014/main" id="{13022399-17F1-43C2-8944-C095BE6CB379}"/>
+                <a16:creationId xmlns:a16="http://schemas.microsoft.com/office/drawing/2014/main" id="{8A1590AA-73E2-4964-829E-45FABCECB2F4}"/>
               </a:ext>
             </a:extLst>
           </p:cNvPr>
@@ -1631,7 +1631,7 @@
           <p:cNvPr id="4" name="">
             <a:extLst xmlns:a="http://schemas.openxmlformats.org/drawingml/2006/main">
               <a:ext uri="{FF2B5EF4-FFF2-40B4-BE49-F238E27FC236}">
-                <a16:creationId xmlns:a16="http://schemas.microsoft.com/office/drawing/2014/main" id="{8EFB3BCB-B97F-4D5B-8FCB-162DC683D0F3}"/>
+                <a16:creationId xmlns:a16="http://schemas.microsoft.com/office/drawing/2014/main" id="{4FB0A1B4-72C2-4DCF-B962-979D28A9A63C}"/>
               </a:ext>
             </a:extLst>
           </p:cNvPr>
@@ -1661,7 +1661,7 @@
           <p:cNvPr id="5" name="">
             <a:extLst xmlns:a="http://schemas.openxmlformats.org/drawingml/2006/main">
               <a:ext uri="{FF2B5EF4-FFF2-40B4-BE49-F238E27FC236}">
-                <a16:creationId xmlns:a16="http://schemas.microsoft.com/office/drawing/2014/main" id="{099D7338-8342-4154-B951-E48A459AF2DB}"/>
+                <a16:creationId xmlns:a16="http://schemas.microsoft.com/office/drawing/2014/main" id="{BC74D646-CF7D-4577-9CB6-57B5EA729302}"/>
               </a:ext>
             </a:extLst>
           </p:cNvPr>
@@ -1691,7 +1691,7 @@
           <p:cNvPr id="6" name="">
             <a:extLst xmlns:a="http://schemas.openxmlformats.org/drawingml/2006/main">
               <a:ext uri="{FF2B5EF4-FFF2-40B4-BE49-F238E27FC236}">
-                <a16:creationId xmlns:a16="http://schemas.microsoft.com/office/drawing/2014/main" id="{C2DD2A9D-93BB-4119-853D-46B93F9CAA21}"/>
+                <a16:creationId xmlns:a16="http://schemas.microsoft.com/office/drawing/2014/main" id="{CD419368-9FE1-485B-8E06-D78D5B87B54E}"/>
               </a:ext>
             </a:extLst>
           </p:cNvPr>
@@ -1748,7 +1748,7 @@
           <p:cNvPr id="7" name="">
             <a:extLst xmlns:a="http://schemas.openxmlformats.org/drawingml/2006/main">
               <a:ext uri="{FF2B5EF4-FFF2-40B4-BE49-F238E27FC236}">
-                <a16:creationId xmlns:a16="http://schemas.microsoft.com/office/drawing/2014/main" id="{3C16DE72-0339-4AA2-8801-EBBA0499CA95}"/>
+                <a16:creationId xmlns:a16="http://schemas.microsoft.com/office/drawing/2014/main" id="{16470E4B-9FCC-4E11-B65D-07C0E6409B51}"/>
               </a:ext>
             </a:extLst>
           </p:cNvPr>
@@ -1805,7 +1805,7 @@
           <p:cNvPr id="8" name="">
             <a:extLst xmlns:a="http://schemas.openxmlformats.org/drawingml/2006/main">
               <a:ext uri="{FF2B5EF4-FFF2-40B4-BE49-F238E27FC236}">
-                <a16:creationId xmlns:a16="http://schemas.microsoft.com/office/drawing/2014/main" id="{F45081E0-A6E9-4642-98B5-C23FBEAF867D}"/>
+                <a16:creationId xmlns:a16="http://schemas.microsoft.com/office/drawing/2014/main" id="{918A4784-2393-47A5-8174-3D0072969F3E}"/>
               </a:ext>
             </a:extLst>
           </p:cNvPr>
@@ -1862,7 +1862,7 @@
           <p:cNvPr id="9" name="">
             <a:extLst xmlns:a="http://schemas.openxmlformats.org/drawingml/2006/main">
               <a:ext uri="{FF2B5EF4-FFF2-40B4-BE49-F238E27FC236}">
-                <a16:creationId xmlns:a16="http://schemas.microsoft.com/office/drawing/2014/main" id="{DC6953EF-6C67-4A4F-BDEF-5C6A6C176E05}"/>
+                <a16:creationId xmlns:a16="http://schemas.microsoft.com/office/drawing/2014/main" id="{4B22037F-8EDB-453A-9C69-E3C999C926F8}"/>
               </a:ext>
             </a:extLst>
           </p:cNvPr>
@@ -1917,7 +1917,7 @@
     </p:spTree>
     <p:extLst>
       <p:ext uri="{BB962C8B-B14F-4D97-AF65-F5344CB8AC3E}">
-        <p14:creationId xmlns:p14="http://schemas.microsoft.com/office/powerpoint/2010/main" val="231436439"/>
+        <p14:creationId xmlns:p14="http://schemas.microsoft.com/office/powerpoint/2010/main" val="1238613018"/>
       </p:ext>
     </p:extLst>
   </p:cSld>
@@ -1948,7 +1948,7 @@
           <p:cNvPr id="8" name="">
             <a:extLst xmlns:a="http://schemas.openxmlformats.org/drawingml/2006/main">
               <a:ext uri="{FF2B5EF4-FFF2-40B4-BE49-F238E27FC236}">
-                <a16:creationId xmlns:a16="http://schemas.microsoft.com/office/drawing/2014/main" id="{BB3DB6E7-89EC-4273-A593-AC4560D8F8E0}"/>
+                <a16:creationId xmlns:a16="http://schemas.microsoft.com/office/drawing/2014/main" id="{F5D6A8BD-EBD5-48C9-BB72-D3DEC68C5217}"/>
               </a:ext>
             </a:extLst>
           </p:cNvPr>
@@ -2005,7 +2005,7 @@
           <p:cNvPr id="2" name="">
             <a:extLst xmlns:a="http://schemas.openxmlformats.org/drawingml/2006/main">
               <a:ext uri="{FF2B5EF4-FFF2-40B4-BE49-F238E27FC236}">
-                <a16:creationId xmlns:a16="http://schemas.microsoft.com/office/drawing/2014/main" id="{953E4CBE-7D0E-4774-B25F-1A93893AC7F5}"/>
+                <a16:creationId xmlns:a16="http://schemas.microsoft.com/office/drawing/2014/main" id="{044E5565-215C-4A3E-8FA7-9D5FE97C497D}"/>
               </a:ext>
             </a:extLst>
           </p:cNvPr>
@@ -2062,7 +2062,7 @@
           <p:cNvPr id="3" name="">
             <a:extLst xmlns:a="http://schemas.openxmlformats.org/drawingml/2006/main">
               <a:ext uri="{FF2B5EF4-FFF2-40B4-BE49-F238E27FC236}">
-                <a16:creationId xmlns:a16="http://schemas.microsoft.com/office/drawing/2014/main" id="{47429EC2-A040-444A-998D-53AFA78AE9F3}"/>
+                <a16:creationId xmlns:a16="http://schemas.microsoft.com/office/drawing/2014/main" id="{98064D36-6310-44D8-95EF-0EFEF58F7537}"/>
               </a:ext>
             </a:extLst>
           </p:cNvPr>
@@ -2142,7 +2142,7 @@
           <p:cNvPr id="4" name="">
             <a:extLst xmlns:a="http://schemas.openxmlformats.org/drawingml/2006/main">
               <a:ext uri="{FF2B5EF4-FFF2-40B4-BE49-F238E27FC236}">
-                <a16:creationId xmlns:a16="http://schemas.microsoft.com/office/drawing/2014/main" id="{0A43DE4E-A1CA-47DF-8ABF-C7DF0CF6D8B9}"/>
+                <a16:creationId xmlns:a16="http://schemas.microsoft.com/office/drawing/2014/main" id="{5A898121-8E49-4230-B04F-C17EBE37BB30}"/>
               </a:ext>
             </a:extLst>
           </p:cNvPr>
@@ -2199,7 +2199,7 @@
           <p:cNvPr id="5" name="">
             <a:extLst xmlns:a="http://schemas.openxmlformats.org/drawingml/2006/main">
               <a:ext uri="{FF2B5EF4-FFF2-40B4-BE49-F238E27FC236}">
-                <a16:creationId xmlns:a16="http://schemas.microsoft.com/office/drawing/2014/main" id="{36471447-EAE0-441E-9E70-164EDF845D77}"/>
+                <a16:creationId xmlns:a16="http://schemas.microsoft.com/office/drawing/2014/main" id="{443BDB5B-A5F3-47A7-93A4-B0C1F1D88A84}"/>
               </a:ext>
             </a:extLst>
           </p:cNvPr>
@@ -2256,7 +2256,7 @@
           <p:cNvPr id="6" name="">
             <a:extLst xmlns:a="http://schemas.openxmlformats.org/drawingml/2006/main">
               <a:ext uri="{FF2B5EF4-FFF2-40B4-BE49-F238E27FC236}">
-                <a16:creationId xmlns:a16="http://schemas.microsoft.com/office/drawing/2014/main" id="{A96BF0CC-939A-469D-BE7D-17293154E0D3}"/>
+                <a16:creationId xmlns:a16="http://schemas.microsoft.com/office/drawing/2014/main" id="{61BEEBD4-C570-4774-9F87-3A09BB3FF670}"/>
               </a:ext>
             </a:extLst>
           </p:cNvPr>
@@ -2371,7 +2371,7 @@
           <p:cNvPr id="7" name="">
             <a:extLst xmlns:a="http://schemas.openxmlformats.org/drawingml/2006/main">
               <a:ext uri="{FF2B5EF4-FFF2-40B4-BE49-F238E27FC236}">
-                <a16:creationId xmlns:a16="http://schemas.microsoft.com/office/drawing/2014/main" id="{E5FF5E3B-9850-4A6C-9425-D6D165A53A19}"/>
+                <a16:creationId xmlns:a16="http://schemas.microsoft.com/office/drawing/2014/main" id="{AF2FBA3D-4E53-4193-8442-AD0054437EF6}"/>
               </a:ext>
             </a:extLst>
           </p:cNvPr>
@@ -2426,7 +2426,7 @@
     </p:spTree>
     <p:extLst>
       <p:ext uri="{BB962C8B-B14F-4D97-AF65-F5344CB8AC3E}">
-        <p14:creationId xmlns:p14="http://schemas.microsoft.com/office/powerpoint/2010/main" val="1737557798"/>
+        <p14:creationId xmlns:p14="http://schemas.microsoft.com/office/powerpoint/2010/main" val="786054344"/>
       </p:ext>
     </p:extLst>
   </p:cSld>
@@ -2457,7 +2457,7 @@
           <p:cNvPr id="16" name="">
             <a:extLst xmlns:a="http://schemas.openxmlformats.org/drawingml/2006/main">
               <a:ext uri="{FF2B5EF4-FFF2-40B4-BE49-F238E27FC236}">
-                <a16:creationId xmlns:a16="http://schemas.microsoft.com/office/drawing/2014/main" id="{7789AE44-F5CD-4112-8FBF-3E570769929B}"/>
+                <a16:creationId xmlns:a16="http://schemas.microsoft.com/office/drawing/2014/main" id="{D233F857-F25F-41F2-A1C5-3C936B0670E4}"/>
               </a:ext>
             </a:extLst>
           </p:cNvPr>
@@ -2514,7 +2514,7 @@
           <p:cNvPr id="2" name="">
             <a:extLst xmlns:a="http://schemas.openxmlformats.org/drawingml/2006/main">
               <a:ext uri="{FF2B5EF4-FFF2-40B4-BE49-F238E27FC236}">
-                <a16:creationId xmlns:a16="http://schemas.microsoft.com/office/drawing/2014/main" id="{B1C5AEDD-B111-4214-B1AD-4B1258B28E49}"/>
+                <a16:creationId xmlns:a16="http://schemas.microsoft.com/office/drawing/2014/main" id="{010EF863-5CDB-44B1-AAF6-E57FEDA32432}"/>
               </a:ext>
             </a:extLst>
           </p:cNvPr>
@@ -2571,7 +2571,7 @@
           <p:cNvPr id="3" name="">
             <a:extLst xmlns:a="http://schemas.openxmlformats.org/drawingml/2006/main">
               <a:ext uri="{FF2B5EF4-FFF2-40B4-BE49-F238E27FC236}">
-                <a16:creationId xmlns:a16="http://schemas.microsoft.com/office/drawing/2014/main" id="{81ADB853-31B2-48F6-B525-4FC78868C061}"/>
+                <a16:creationId xmlns:a16="http://schemas.microsoft.com/office/drawing/2014/main" id="{20D26D12-DC3B-43DE-8B32-82431CDF56AE}"/>
               </a:ext>
             </a:extLst>
           </p:cNvPr>
@@ -2628,7 +2628,7 @@
           <p:cNvPr id="4" name="">
             <a:extLst xmlns:a="http://schemas.openxmlformats.org/drawingml/2006/main">
               <a:ext uri="{FF2B5EF4-FFF2-40B4-BE49-F238E27FC236}">
-                <a16:creationId xmlns:a16="http://schemas.microsoft.com/office/drawing/2014/main" id="{1BEB30F1-C5E0-4872-ACC0-C88ECE7C38EC}"/>
+                <a16:creationId xmlns:a16="http://schemas.microsoft.com/office/drawing/2014/main" id="{2F2570C0-EFED-4DAF-9C21-23B1BECBB1F6}"/>
               </a:ext>
             </a:extLst>
           </p:cNvPr>
@@ -2716,7 +2716,7 @@
           <p:cNvPr id="5" name="">
             <a:extLst xmlns:a="http://schemas.openxmlformats.org/drawingml/2006/main">
               <a:ext uri="{FF2B5EF4-FFF2-40B4-BE49-F238E27FC236}">
-                <a16:creationId xmlns:a16="http://schemas.microsoft.com/office/drawing/2014/main" id="{202D69FF-638F-4611-B658-5E126688061E}"/>
+                <a16:creationId xmlns:a16="http://schemas.microsoft.com/office/drawing/2014/main" id="{678054EE-11C9-41AA-933B-3D8B237541D4}"/>
               </a:ext>
             </a:extLst>
           </p:cNvPr>
@@ -2796,7 +2796,7 @@
           <p:cNvPr id="6" name="">
             <a:extLst xmlns:a="http://schemas.openxmlformats.org/drawingml/2006/main">
               <a:ext uri="{FF2B5EF4-FFF2-40B4-BE49-F238E27FC236}">
-                <a16:creationId xmlns:a16="http://schemas.microsoft.com/office/drawing/2014/main" id="{D7A7CD1A-AEFD-4868-B4F5-AFF6ED79B332}"/>
+                <a16:creationId xmlns:a16="http://schemas.microsoft.com/office/drawing/2014/main" id="{4459C308-8FA9-4C39-B62D-C63D2E7D9B67}"/>
               </a:ext>
             </a:extLst>
           </p:cNvPr>
@@ -2828,7 +2828,7 @@
           <p:cNvPr id="7" name="">
             <a:extLst xmlns:a="http://schemas.openxmlformats.org/drawingml/2006/main">
               <a:ext uri="{FF2B5EF4-FFF2-40B4-BE49-F238E27FC236}">
-                <a16:creationId xmlns:a16="http://schemas.microsoft.com/office/drawing/2014/main" id="{0B8665EC-ED3C-4656-8F3F-26733A7BF74D}"/>
+                <a16:creationId xmlns:a16="http://schemas.microsoft.com/office/drawing/2014/main" id="{3B03CB09-3F41-4382-BA6F-4BD40C6BE315}"/>
               </a:ext>
             </a:extLst>
           </p:cNvPr>
@@ -2858,7 +2858,7 @@
           <p:cNvPr id="8" name="">
             <a:extLst xmlns:a="http://schemas.openxmlformats.org/drawingml/2006/main">
               <a:ext uri="{FF2B5EF4-FFF2-40B4-BE49-F238E27FC236}">
-                <a16:creationId xmlns:a16="http://schemas.microsoft.com/office/drawing/2014/main" id="{0D9F1539-21CC-4EB7-972E-EE63C8A10A49}"/>
+                <a16:creationId xmlns:a16="http://schemas.microsoft.com/office/drawing/2014/main" id="{D1CA1117-6D9B-4E7C-AAAF-A9C29AF743DE}"/>
               </a:ext>
             </a:extLst>
           </p:cNvPr>
@@ -2915,7 +2915,7 @@
           <p:cNvPr id="9" name="">
             <a:extLst xmlns:a="http://schemas.openxmlformats.org/drawingml/2006/main">
               <a:ext uri="{FF2B5EF4-FFF2-40B4-BE49-F238E27FC236}">
-                <a16:creationId xmlns:a16="http://schemas.microsoft.com/office/drawing/2014/main" id="{4D5D6625-2118-469E-B72B-71BADC9DF564}"/>
+                <a16:creationId xmlns:a16="http://schemas.microsoft.com/office/drawing/2014/main" id="{FBF23565-55E2-4AD6-A832-AC2B5080A2AD}"/>
               </a:ext>
             </a:extLst>
           </p:cNvPr>
@@ -2972,7 +2972,7 @@
           <p:cNvPr id="10" name="">
             <a:extLst xmlns:a="http://schemas.openxmlformats.org/drawingml/2006/main">
               <a:ext uri="{FF2B5EF4-FFF2-40B4-BE49-F238E27FC236}">
-                <a16:creationId xmlns:a16="http://schemas.microsoft.com/office/drawing/2014/main" id="{EE9809D9-1B4D-440A-A2F1-EBCF90D56152}"/>
+                <a16:creationId xmlns:a16="http://schemas.microsoft.com/office/drawing/2014/main" id="{4B063A3D-D780-40F6-B806-184758684185}"/>
               </a:ext>
             </a:extLst>
           </p:cNvPr>
@@ -3029,7 +3029,7 @@
           <p:cNvPr id="11" name="">
             <a:extLst xmlns:a="http://schemas.openxmlformats.org/drawingml/2006/main">
               <a:ext uri="{FF2B5EF4-FFF2-40B4-BE49-F238E27FC236}">
-                <a16:creationId xmlns:a16="http://schemas.microsoft.com/office/drawing/2014/main" id="{E1E295C9-FE01-420F-A9D1-8276B33812E0}"/>
+                <a16:creationId xmlns:a16="http://schemas.microsoft.com/office/drawing/2014/main" id="{79CAEA50-D586-42D2-95BA-B318C9386E57}"/>
               </a:ext>
             </a:extLst>
           </p:cNvPr>
@@ -3086,7 +3086,7 @@
           <p:cNvPr id="12" name="">
             <a:extLst xmlns:a="http://schemas.openxmlformats.org/drawingml/2006/main">
               <a:ext uri="{FF2B5EF4-FFF2-40B4-BE49-F238E27FC236}">
-                <a16:creationId xmlns:a16="http://schemas.microsoft.com/office/drawing/2014/main" id="{9708FBB8-8042-4DF3-81C7-CE67009069B8}"/>
+                <a16:creationId xmlns:a16="http://schemas.microsoft.com/office/drawing/2014/main" id="{01EC630D-7344-46EB-B5FF-43A0683008D3}"/>
               </a:ext>
             </a:extLst>
           </p:cNvPr>
@@ -3166,7 +3166,7 @@
           <p:cNvPr id="13" name="">
             <a:extLst xmlns:a="http://schemas.openxmlformats.org/drawingml/2006/main">
               <a:ext uri="{FF2B5EF4-FFF2-40B4-BE49-F238E27FC236}">
-                <a16:creationId xmlns:a16="http://schemas.microsoft.com/office/drawing/2014/main" id="{E1D89C8C-F00B-4B5A-9CB9-910809B3469C}"/>
+                <a16:creationId xmlns:a16="http://schemas.microsoft.com/office/drawing/2014/main" id="{C1A3BC76-DEAC-43D5-B89E-B5EB0F7F5D18}"/>
               </a:ext>
             </a:extLst>
           </p:cNvPr>
@@ -3223,7 +3223,7 @@
           <p:cNvPr id="14" name="">
             <a:extLst xmlns:a="http://schemas.openxmlformats.org/drawingml/2006/main">
               <a:ext uri="{FF2B5EF4-FFF2-40B4-BE49-F238E27FC236}">
-                <a16:creationId xmlns:a16="http://schemas.microsoft.com/office/drawing/2014/main" id="{AF8D011A-597E-4AFB-82F3-F31A3F8BE59B}"/>
+                <a16:creationId xmlns:a16="http://schemas.microsoft.com/office/drawing/2014/main" id="{5C9E83F0-B426-47BD-8410-9C1BE7D8B968}"/>
               </a:ext>
             </a:extLst>
           </p:cNvPr>
@@ -3280,7 +3280,7 @@
           <p:cNvPr id="15" name="">
             <a:extLst xmlns:a="http://schemas.openxmlformats.org/drawingml/2006/main">
               <a:ext uri="{FF2B5EF4-FFF2-40B4-BE49-F238E27FC236}">
-                <a16:creationId xmlns:a16="http://schemas.microsoft.com/office/drawing/2014/main" id="{6868F07D-215A-4800-9C06-A3DDDD62CB7F}"/>
+                <a16:creationId xmlns:a16="http://schemas.microsoft.com/office/drawing/2014/main" id="{FA84A153-D43D-48B4-89E6-6D4CAA51F262}"/>
               </a:ext>
             </a:extLst>
           </p:cNvPr>
@@ -3335,7 +3335,7 @@
     </p:spTree>
     <p:extLst>
       <p:ext uri="{BB962C8B-B14F-4D97-AF65-F5344CB8AC3E}">
-        <p14:creationId xmlns:p14="http://schemas.microsoft.com/office/powerpoint/2010/main" val="1000687011"/>
+        <p14:creationId xmlns:p14="http://schemas.microsoft.com/office/powerpoint/2010/main" val="426658300"/>
       </p:ext>
     </p:extLst>
   </p:cSld>
@@ -3366,7 +3366,7 @@
           <p:cNvPr id="21" name="">
             <a:extLst xmlns:a="http://schemas.openxmlformats.org/drawingml/2006/main">
               <a:ext uri="{FF2B5EF4-FFF2-40B4-BE49-F238E27FC236}">
-                <a16:creationId xmlns:a16="http://schemas.microsoft.com/office/drawing/2014/main" id="{DAEAFA77-90F6-41F4-90C0-42E5D78DD572}"/>
+                <a16:creationId xmlns:a16="http://schemas.microsoft.com/office/drawing/2014/main" id="{02E8174B-C674-493B-8379-67B82246543B}"/>
               </a:ext>
             </a:extLst>
           </p:cNvPr>
@@ -3423,7 +3423,7 @@
           <p:cNvPr id="2" name="">
             <a:extLst xmlns:a="http://schemas.openxmlformats.org/drawingml/2006/main">
               <a:ext uri="{FF2B5EF4-FFF2-40B4-BE49-F238E27FC236}">
-                <a16:creationId xmlns:a16="http://schemas.microsoft.com/office/drawing/2014/main" id="{E3B1F275-5F3D-4672-93B9-C1A95220AF42}"/>
+                <a16:creationId xmlns:a16="http://schemas.microsoft.com/office/drawing/2014/main" id="{FFA49EB5-EF83-429F-A7B8-CB98F4F7ABF9}"/>
               </a:ext>
             </a:extLst>
           </p:cNvPr>
@@ -3480,7 +3480,7 @@
           <p:cNvPr id="3" name="">
             <a:extLst xmlns:a="http://schemas.openxmlformats.org/drawingml/2006/main">
               <a:ext uri="{FF2B5EF4-FFF2-40B4-BE49-F238E27FC236}">
-                <a16:creationId xmlns:a16="http://schemas.microsoft.com/office/drawing/2014/main" id="{295DA63F-3CC9-4B10-B0C1-8B1444BDE7C8}"/>
+                <a16:creationId xmlns:a16="http://schemas.microsoft.com/office/drawing/2014/main" id="{0E951D40-00F2-49A3-8DDB-51293829FAE8}"/>
               </a:ext>
             </a:extLst>
           </p:cNvPr>
@@ -3537,7 +3537,7 @@
           <p:cNvPr id="4" name="">
             <a:extLst xmlns:a="http://schemas.openxmlformats.org/drawingml/2006/main">
               <a:ext uri="{FF2B5EF4-FFF2-40B4-BE49-F238E27FC236}">
-                <a16:creationId xmlns:a16="http://schemas.microsoft.com/office/drawing/2014/main" id="{0C4B4C2F-4D43-4024-AAA1-121DD916E3B4}"/>
+                <a16:creationId xmlns:a16="http://schemas.microsoft.com/office/drawing/2014/main" id="{4A01BB67-1BD0-4FC1-AFB3-F41FE6730E3E}"/>
               </a:ext>
             </a:extLst>
           </p:cNvPr>
@@ -3594,7 +3594,7 @@
           <p:cNvPr id="5" name="">
             <a:extLst xmlns:a="http://schemas.openxmlformats.org/drawingml/2006/main">
               <a:ext uri="{FF2B5EF4-FFF2-40B4-BE49-F238E27FC236}">
-                <a16:creationId xmlns:a16="http://schemas.microsoft.com/office/drawing/2014/main" id="{3B4A118C-B9E2-4A98-8FBC-77296709D1AF}"/>
+                <a16:creationId xmlns:a16="http://schemas.microsoft.com/office/drawing/2014/main" id="{F9BC91C3-B97C-40B6-A6C0-EC5FFD0B072E}"/>
               </a:ext>
             </a:extLst>
           </p:cNvPr>
@@ -3651,7 +3651,7 @@
           <p:cNvPr id="6" name="">
             <a:extLst xmlns:a="http://schemas.openxmlformats.org/drawingml/2006/main">
               <a:ext uri="{FF2B5EF4-FFF2-40B4-BE49-F238E27FC236}">
-                <a16:creationId xmlns:a16="http://schemas.microsoft.com/office/drawing/2014/main" id="{3315B8CA-D887-4396-B606-8F0C3F835612}"/>
+                <a16:creationId xmlns:a16="http://schemas.microsoft.com/office/drawing/2014/main" id="{88F2E3C0-03FA-43BF-9094-221745416C2E}"/>
               </a:ext>
             </a:extLst>
           </p:cNvPr>
@@ -3681,7 +3681,7 @@
           <p:cNvPr id="7" name="">
             <a:extLst xmlns:a="http://schemas.openxmlformats.org/drawingml/2006/main">
               <a:ext uri="{FF2B5EF4-FFF2-40B4-BE49-F238E27FC236}">
-                <a16:creationId xmlns:a16="http://schemas.microsoft.com/office/drawing/2014/main" id="{FA35D116-5456-425F-97E8-635E5A0AC3EF}"/>
+                <a16:creationId xmlns:a16="http://schemas.microsoft.com/office/drawing/2014/main" id="{7FDD8247-2FB9-4BC9-8B88-58671C79ACAC}"/>
               </a:ext>
             </a:extLst>
           </p:cNvPr>
@@ -3738,7 +3738,7 @@
           <p:cNvPr id="8" name="">
             <a:extLst xmlns:a="http://schemas.openxmlformats.org/drawingml/2006/main">
               <a:ext uri="{FF2B5EF4-FFF2-40B4-BE49-F238E27FC236}">
-                <a16:creationId xmlns:a16="http://schemas.microsoft.com/office/drawing/2014/main" id="{8B563A3B-41F0-4F12-8B05-40AC97855B42}"/>
+                <a16:creationId xmlns:a16="http://schemas.microsoft.com/office/drawing/2014/main" id="{E09E0DFF-39D0-4E10-952B-502DDB88219F}"/>
               </a:ext>
             </a:extLst>
           </p:cNvPr>
@@ -3818,7 +3818,7 @@
           <p:cNvPr id="9" name="">
             <a:extLst xmlns:a="http://schemas.openxmlformats.org/drawingml/2006/main">
               <a:ext uri="{FF2B5EF4-FFF2-40B4-BE49-F238E27FC236}">
-                <a16:creationId xmlns:a16="http://schemas.microsoft.com/office/drawing/2014/main" id="{C533F80C-1E76-4457-A687-F701DE84F847}"/>
+                <a16:creationId xmlns:a16="http://schemas.microsoft.com/office/drawing/2014/main" id="{759EFBD9-BFF2-4A52-BAA2-FA09C4CCEA78}"/>
               </a:ext>
             </a:extLst>
           </p:cNvPr>
@@ -3875,7 +3875,7 @@
           <p:cNvPr id="10" name="">
             <a:extLst xmlns:a="http://schemas.openxmlformats.org/drawingml/2006/main">
               <a:ext uri="{FF2B5EF4-FFF2-40B4-BE49-F238E27FC236}">
-                <a16:creationId xmlns:a16="http://schemas.microsoft.com/office/drawing/2014/main" id="{F955FC33-95F0-447B-BDA7-4AB4FB0A06EF}"/>
+                <a16:creationId xmlns:a16="http://schemas.microsoft.com/office/drawing/2014/main" id="{472FE0FF-066F-49C8-9544-14DE45C10D8A}"/>
               </a:ext>
             </a:extLst>
           </p:cNvPr>
@@ -3905,7 +3905,7 @@
           <p:cNvPr id="11" name="">
             <a:extLst xmlns:a="http://schemas.openxmlformats.org/drawingml/2006/main">
               <a:ext uri="{FF2B5EF4-FFF2-40B4-BE49-F238E27FC236}">
-                <a16:creationId xmlns:a16="http://schemas.microsoft.com/office/drawing/2014/main" id="{D65A77B2-0556-4EDD-8102-66ED0D39D50D}"/>
+                <a16:creationId xmlns:a16="http://schemas.microsoft.com/office/drawing/2014/main" id="{45A6A38B-1628-42C5-8124-851D9AC0EB8F}"/>
               </a:ext>
             </a:extLst>
           </p:cNvPr>
@@ -3962,7 +3962,7 @@
           <p:cNvPr id="12" name="">
             <a:extLst xmlns:a="http://schemas.openxmlformats.org/drawingml/2006/main">
               <a:ext uri="{FF2B5EF4-FFF2-40B4-BE49-F238E27FC236}">
-                <a16:creationId xmlns:a16="http://schemas.microsoft.com/office/drawing/2014/main" id="{14E78BD8-5443-4E80-A8B7-8CB7F1D76E4B}"/>
+                <a16:creationId xmlns:a16="http://schemas.microsoft.com/office/drawing/2014/main" id="{B0B27333-8117-424A-A965-0C2E4F21A536}"/>
               </a:ext>
             </a:extLst>
           </p:cNvPr>
@@ -4042,7 +4042,7 @@
           <p:cNvPr id="13" name="">
             <a:extLst xmlns:a="http://schemas.openxmlformats.org/drawingml/2006/main">
               <a:ext uri="{FF2B5EF4-FFF2-40B4-BE49-F238E27FC236}">
-                <a16:creationId xmlns:a16="http://schemas.microsoft.com/office/drawing/2014/main" id="{AA755F7B-E926-4F3F-A590-0ABA49F89944}"/>
+                <a16:creationId xmlns:a16="http://schemas.microsoft.com/office/drawing/2014/main" id="{878D59B6-4D00-4EE2-8D57-352D2593797A}"/>
               </a:ext>
             </a:extLst>
           </p:cNvPr>
@@ -4099,7 +4099,7 @@
           <p:cNvPr id="14" name="">
             <a:extLst xmlns:a="http://schemas.openxmlformats.org/drawingml/2006/main">
               <a:ext uri="{FF2B5EF4-FFF2-40B4-BE49-F238E27FC236}">
-                <a16:creationId xmlns:a16="http://schemas.microsoft.com/office/drawing/2014/main" id="{E565138D-96B8-4AA5-AF97-D3B714B4D7F4}"/>
+                <a16:creationId xmlns:a16="http://schemas.microsoft.com/office/drawing/2014/main" id="{F1E7A77E-3343-48E8-8F44-1FF6189D05AE}"/>
               </a:ext>
             </a:extLst>
           </p:cNvPr>
@@ -4129,7 +4129,7 @@
           <p:cNvPr id="15" name="">
             <a:extLst xmlns:a="http://schemas.openxmlformats.org/drawingml/2006/main">
               <a:ext uri="{FF2B5EF4-FFF2-40B4-BE49-F238E27FC236}">
-                <a16:creationId xmlns:a16="http://schemas.microsoft.com/office/drawing/2014/main" id="{D4398AE9-9698-46D8-AF7B-A5F7657A0C35}"/>
+                <a16:creationId xmlns:a16="http://schemas.microsoft.com/office/drawing/2014/main" id="{DD2A295F-A18B-43A9-9A40-5CB228D2A966}"/>
               </a:ext>
             </a:extLst>
           </p:cNvPr>
@@ -4186,7 +4186,7 @@
           <p:cNvPr id="16" name="">
             <a:extLst xmlns:a="http://schemas.openxmlformats.org/drawingml/2006/main">
               <a:ext uri="{FF2B5EF4-FFF2-40B4-BE49-F238E27FC236}">
-                <a16:creationId xmlns:a16="http://schemas.microsoft.com/office/drawing/2014/main" id="{B5C6EFDE-E583-4BF2-B135-D086D37FED88}"/>
+                <a16:creationId xmlns:a16="http://schemas.microsoft.com/office/drawing/2014/main" id="{3A6AB60A-2B2C-4D49-988F-72C1C5AF0256}"/>
               </a:ext>
             </a:extLst>
           </p:cNvPr>
@@ -4266,7 +4266,7 @@
           <p:cNvPr id="17" name="">
             <a:extLst xmlns:a="http://schemas.openxmlformats.org/drawingml/2006/main">
               <a:ext uri="{FF2B5EF4-FFF2-40B4-BE49-F238E27FC236}">
-                <a16:creationId xmlns:a16="http://schemas.microsoft.com/office/drawing/2014/main" id="{1C7FAC75-92FA-476C-85DD-8ECBB6586BCD}"/>
+                <a16:creationId xmlns:a16="http://schemas.microsoft.com/office/drawing/2014/main" id="{1767573B-AF12-45E1-AA69-17765CA1CFCD}"/>
               </a:ext>
             </a:extLst>
           </p:cNvPr>
@@ -4323,7 +4323,7 @@
           <p:cNvPr id="18" name="">
             <a:extLst xmlns:a="http://schemas.openxmlformats.org/drawingml/2006/main">
               <a:ext uri="{FF2B5EF4-FFF2-40B4-BE49-F238E27FC236}">
-                <a16:creationId xmlns:a16="http://schemas.microsoft.com/office/drawing/2014/main" id="{5FFFC64B-FAE1-4588-87D9-95CBE6F7C65F}"/>
+                <a16:creationId xmlns:a16="http://schemas.microsoft.com/office/drawing/2014/main" id="{D65F959E-8E97-40E5-B8D5-C34EF67FF082}"/>
               </a:ext>
             </a:extLst>
           </p:cNvPr>
@@ -4353,7 +4353,7 @@
           <p:cNvPr id="19" name="">
             <a:extLst xmlns:a="http://schemas.openxmlformats.org/drawingml/2006/main">
               <a:ext uri="{FF2B5EF4-FFF2-40B4-BE49-F238E27FC236}">
-                <a16:creationId xmlns:a16="http://schemas.microsoft.com/office/drawing/2014/main" id="{D48009E9-C69F-4A51-AE7F-E6A7464DC1AB}"/>
+                <a16:creationId xmlns:a16="http://schemas.microsoft.com/office/drawing/2014/main" id="{3504B0BF-C867-49D5-B6F3-6B534C16442A}"/>
               </a:ext>
             </a:extLst>
           </p:cNvPr>
@@ -4410,7 +4410,7 @@
           <p:cNvPr id="20" name="">
             <a:extLst xmlns:a="http://schemas.openxmlformats.org/drawingml/2006/main">
               <a:ext uri="{FF2B5EF4-FFF2-40B4-BE49-F238E27FC236}">
-                <a16:creationId xmlns:a16="http://schemas.microsoft.com/office/drawing/2014/main" id="{B6262B3C-1C12-44F4-93C1-2ACCFF3341BE}"/>
+                <a16:creationId xmlns:a16="http://schemas.microsoft.com/office/drawing/2014/main" id="{20B66C2C-070F-4775-9872-55B21E0A020B}"/>
               </a:ext>
             </a:extLst>
           </p:cNvPr>
@@ -4488,7 +4488,7 @@
     </p:spTree>
     <p:extLst>
       <p:ext uri="{BB962C8B-B14F-4D97-AF65-F5344CB8AC3E}">
-        <p14:creationId xmlns:p14="http://schemas.microsoft.com/office/powerpoint/2010/main" val="595951615"/>
+        <p14:creationId xmlns:p14="http://schemas.microsoft.com/office/powerpoint/2010/main" val="797310768"/>
       </p:ext>
     </p:extLst>
   </p:cSld>
@@ -4519,7 +4519,7 @@
           <p:cNvPr id="6" name="">
             <a:extLst xmlns:a="http://schemas.openxmlformats.org/drawingml/2006/main">
               <a:ext uri="{FF2B5EF4-FFF2-40B4-BE49-F238E27FC236}">
-                <a16:creationId xmlns:a16="http://schemas.microsoft.com/office/drawing/2014/main" id="{025DCD69-9D4E-4620-BA79-8F1A5B9563E4}"/>
+                <a16:creationId xmlns:a16="http://schemas.microsoft.com/office/drawing/2014/main" id="{82BADFBF-0595-4A3E-BEBE-CF0DAA0F84D0}"/>
               </a:ext>
             </a:extLst>
           </p:cNvPr>
@@ -4576,7 +4576,7 @@
           <p:cNvPr id="2" name="">
             <a:extLst xmlns:a="http://schemas.openxmlformats.org/drawingml/2006/main">
               <a:ext uri="{FF2B5EF4-FFF2-40B4-BE49-F238E27FC236}">
-                <a16:creationId xmlns:a16="http://schemas.microsoft.com/office/drawing/2014/main" id="{5BBFCEDE-7FBD-4092-89EA-AFDF05B95AE4}"/>
+                <a16:creationId xmlns:a16="http://schemas.microsoft.com/office/drawing/2014/main" id="{80D777A0-B18D-4BAE-90B9-6E0F8BB42411}"/>
               </a:ext>
             </a:extLst>
           </p:cNvPr>
@@ -4633,7 +4633,7 @@
           <p:cNvPr id="3" name="">
             <a:extLst xmlns:a="http://schemas.openxmlformats.org/drawingml/2006/main">
               <a:ext uri="{FF2B5EF4-FFF2-40B4-BE49-F238E27FC236}">
-                <a16:creationId xmlns:a16="http://schemas.microsoft.com/office/drawing/2014/main" id="{3FDAFA92-3169-4908-9BB0-297B5CA3477A}"/>
+                <a16:creationId xmlns:a16="http://schemas.microsoft.com/office/drawing/2014/main" id="{F34F475E-54F1-4EBB-ABA5-BAFE39B48144}"/>
               </a:ext>
             </a:extLst>
           </p:cNvPr>
@@ -4962,7 +4962,7 @@
           <p:cNvPr id="5" name="">
             <a:extLst xmlns:a="http://schemas.openxmlformats.org/drawingml/2006/main">
               <a:ext uri="{FF2B5EF4-FFF2-40B4-BE49-F238E27FC236}">
-                <a16:creationId xmlns:a16="http://schemas.microsoft.com/office/drawing/2014/main" id="{3C4D4CCA-0F30-4820-858F-6B174A55801B}"/>
+                <a16:creationId xmlns:a16="http://schemas.microsoft.com/office/drawing/2014/main" id="{3623B985-3B70-4D41-B504-0A0F5D9A50B1}"/>
               </a:ext>
             </a:extLst>
           </p:cNvPr>
@@ -5040,7 +5040,7 @@
     </p:spTree>
     <p:extLst>
       <p:ext uri="{BB962C8B-B14F-4D97-AF65-F5344CB8AC3E}">
-        <p14:creationId xmlns:p14="http://schemas.microsoft.com/office/powerpoint/2010/main" val="1833516265"/>
+        <p14:creationId xmlns:p14="http://schemas.microsoft.com/office/powerpoint/2010/main" val="1941566857"/>
       </p:ext>
     </p:extLst>
   </p:cSld>
@@ -5071,7 +5071,7 @@
           <p:cNvPr id="11" name="">
             <a:extLst xmlns:a="http://schemas.openxmlformats.org/drawingml/2006/main">
               <a:ext uri="{FF2B5EF4-FFF2-40B4-BE49-F238E27FC236}">
-                <a16:creationId xmlns:a16="http://schemas.microsoft.com/office/drawing/2014/main" id="{614B6B01-0EF7-4AA5-8E68-F191C4E5FB9F}"/>
+                <a16:creationId xmlns:a16="http://schemas.microsoft.com/office/drawing/2014/main" id="{8BBBE7E7-9FD3-4ADE-B8E6-F396C9B7772D}"/>
               </a:ext>
             </a:extLst>
           </p:cNvPr>
@@ -5128,7 +5128,7 @@
           <p:cNvPr id="2" name="">
             <a:extLst xmlns:a="http://schemas.openxmlformats.org/drawingml/2006/main">
               <a:ext uri="{FF2B5EF4-FFF2-40B4-BE49-F238E27FC236}">
-                <a16:creationId xmlns:a16="http://schemas.microsoft.com/office/drawing/2014/main" id="{1C57ABBA-0937-49CD-B1DE-D959F87A6F94}"/>
+                <a16:creationId xmlns:a16="http://schemas.microsoft.com/office/drawing/2014/main" id="{FB6042F5-E044-4C49-B705-A11B01A192F6}"/>
               </a:ext>
             </a:extLst>
           </p:cNvPr>
@@ -5185,7 +5185,7 @@
           <p:cNvPr id="3" name="">
             <a:extLst xmlns:a="http://schemas.openxmlformats.org/drawingml/2006/main">
               <a:ext uri="{FF2B5EF4-FFF2-40B4-BE49-F238E27FC236}">
-                <a16:creationId xmlns:a16="http://schemas.microsoft.com/office/drawing/2014/main" id="{7785C53F-021E-4EE4-8329-B7AA4E605D6A}"/>
+                <a16:creationId xmlns:a16="http://schemas.microsoft.com/office/drawing/2014/main" id="{917AC362-D8F9-4166-81CA-406E689F7608}"/>
               </a:ext>
             </a:extLst>
           </p:cNvPr>
@@ -5242,7 +5242,7 @@
           <p:cNvPr id="4" name="">
             <a:extLst xmlns:a="http://schemas.openxmlformats.org/drawingml/2006/main">
               <a:ext uri="{FF2B5EF4-FFF2-40B4-BE49-F238E27FC236}">
-                <a16:creationId xmlns:a16="http://schemas.microsoft.com/office/drawing/2014/main" id="{15BC4A3E-13B3-4AB2-876C-D89E80AB1C3A}"/>
+                <a16:creationId xmlns:a16="http://schemas.microsoft.com/office/drawing/2014/main" id="{EC897F21-C572-4463-B00B-1D1A0A7EDCD5}"/>
               </a:ext>
             </a:extLst>
           </p:cNvPr>
@@ -5299,7 +5299,7 @@
           <p:cNvPr id="5" name="">
             <a:extLst xmlns:a="http://schemas.openxmlformats.org/drawingml/2006/main">
               <a:ext uri="{FF2B5EF4-FFF2-40B4-BE49-F238E27FC236}">
-                <a16:creationId xmlns:a16="http://schemas.microsoft.com/office/drawing/2014/main" id="{49ECE3D3-5EE5-4F7A-BA9B-00864EAA9678}"/>
+                <a16:creationId xmlns:a16="http://schemas.microsoft.com/office/drawing/2014/main" id="{44F5BB5B-7148-42F1-AFC0-7B491EE96E49}"/>
               </a:ext>
             </a:extLst>
           </p:cNvPr>
@@ -5356,7 +5356,7 @@
           <p:cNvPr id="6" name="">
             <a:extLst xmlns:a="http://schemas.openxmlformats.org/drawingml/2006/main">
               <a:ext uri="{FF2B5EF4-FFF2-40B4-BE49-F238E27FC236}">
-                <a16:creationId xmlns:a16="http://schemas.microsoft.com/office/drawing/2014/main" id="{1FE96AC1-34A9-44C8-90F1-4062502A8281}"/>
+                <a16:creationId xmlns:a16="http://schemas.microsoft.com/office/drawing/2014/main" id="{1C013845-A27C-41BB-9712-7A959B03BB8D}"/>
               </a:ext>
             </a:extLst>
           </p:cNvPr>
@@ -5413,7 +5413,7 @@
           <p:cNvPr id="7" name="">
             <a:extLst xmlns:a="http://schemas.openxmlformats.org/drawingml/2006/main">
               <a:ext uri="{FF2B5EF4-FFF2-40B4-BE49-F238E27FC236}">
-                <a16:creationId xmlns:a16="http://schemas.microsoft.com/office/drawing/2014/main" id="{0C945CC5-C867-4B66-A42E-708089EA0201}"/>
+                <a16:creationId xmlns:a16="http://schemas.microsoft.com/office/drawing/2014/main" id="{22BF40EE-9280-4947-83FE-4CC104A731AD}"/>
               </a:ext>
             </a:extLst>
           </p:cNvPr>
@@ -5470,7 +5470,7 @@
           <p:cNvPr id="8" name="">
             <a:extLst xmlns:a="http://schemas.openxmlformats.org/drawingml/2006/main">
               <a:ext uri="{FF2B5EF4-FFF2-40B4-BE49-F238E27FC236}">
-                <a16:creationId xmlns:a16="http://schemas.microsoft.com/office/drawing/2014/main" id="{17DF4227-ACB3-4DF3-96B0-9B560F460CE1}"/>
+                <a16:creationId xmlns:a16="http://schemas.microsoft.com/office/drawing/2014/main" id="{65BC9FA4-F16B-4211-99F1-4275FB191EE3}"/>
               </a:ext>
             </a:extLst>
           </p:cNvPr>
@@ -5527,7 +5527,7 @@
           <p:cNvPr id="9" name="">
             <a:extLst xmlns:a="http://schemas.openxmlformats.org/drawingml/2006/main">
               <a:ext uri="{FF2B5EF4-FFF2-40B4-BE49-F238E27FC236}">
-                <a16:creationId xmlns:a16="http://schemas.microsoft.com/office/drawing/2014/main" id="{878FA969-EF1C-49DF-A542-C8E04277AA67}"/>
+                <a16:creationId xmlns:a16="http://schemas.microsoft.com/office/drawing/2014/main" id="{A2B54FDB-D35C-4E8E-9421-61F19B460B85}"/>
               </a:ext>
             </a:extLst>
           </p:cNvPr>
@@ -5584,7 +5584,7 @@
           <p:cNvPr id="10" name="">
             <a:extLst xmlns:a="http://schemas.openxmlformats.org/drawingml/2006/main">
               <a:ext uri="{FF2B5EF4-FFF2-40B4-BE49-F238E27FC236}">
-                <a16:creationId xmlns:a16="http://schemas.microsoft.com/office/drawing/2014/main" id="{000F3A4D-F280-4D58-B8B6-6939D8EE6AE2}"/>
+                <a16:creationId xmlns:a16="http://schemas.microsoft.com/office/drawing/2014/main" id="{B8F0CB99-8C12-4613-A364-AAAF7FCEF694}"/>
               </a:ext>
             </a:extLst>
           </p:cNvPr>
@@ -5662,7 +5662,7 @@
     </p:spTree>
     <p:extLst>
       <p:ext uri="{BB962C8B-B14F-4D97-AF65-F5344CB8AC3E}">
-        <p14:creationId xmlns:p14="http://schemas.microsoft.com/office/powerpoint/2010/main" val="1321975807"/>
+        <p14:creationId xmlns:p14="http://schemas.microsoft.com/office/powerpoint/2010/main" val="789274086"/>
       </p:ext>
     </p:extLst>
   </p:cSld>
@@ -5690,10 +5690,10 @@
       </p:grpSpPr>
       <p:sp>
         <p:nvSpPr>
-          <p:cNvPr id="9" name="">
-            <a:extLst xmlns:a="http://schemas.openxmlformats.org/drawingml/2006/main">
-              <a:ext uri="{FF2B5EF4-FFF2-40B4-BE49-F238E27FC236}">
-                <a16:creationId xmlns:a16="http://schemas.microsoft.com/office/drawing/2014/main" id="{58D5FD75-5E7D-4202-8CB3-9F67C78AE492}"/>
+          <p:cNvPr id="10" name="">
+            <a:extLst xmlns:a="http://schemas.openxmlformats.org/drawingml/2006/main">
+              <a:ext uri="{FF2B5EF4-FFF2-40B4-BE49-F238E27FC236}">
+                <a16:creationId xmlns:a16="http://schemas.microsoft.com/office/drawing/2014/main" id="{2CDEF396-67A4-417C-A3E4-045C469125CC}"/>
               </a:ext>
             </a:extLst>
           </p:cNvPr>
@@ -5750,7 +5750,7 @@
           <p:cNvPr id="2" name="">
             <a:extLst xmlns:a="http://schemas.openxmlformats.org/drawingml/2006/main">
               <a:ext uri="{FF2B5EF4-FFF2-40B4-BE49-F238E27FC236}">
-                <a16:creationId xmlns:a16="http://schemas.microsoft.com/office/drawing/2014/main" id="{9D4B0D8F-DB14-4FA4-8DCE-FEF1756ABD18}"/>
+                <a16:creationId xmlns:a16="http://schemas.microsoft.com/office/drawing/2014/main" id="{31BFC99D-0317-4329-9AC9-37C732E7EB0F}"/>
               </a:ext>
             </a:extLst>
           </p:cNvPr>
@@ -5807,7 +5807,7 @@
           <p:cNvPr id="3" name="">
             <a:extLst xmlns:a="http://schemas.openxmlformats.org/drawingml/2006/main">
               <a:ext uri="{FF2B5EF4-FFF2-40B4-BE49-F238E27FC236}">
-                <a16:creationId xmlns:a16="http://schemas.microsoft.com/office/drawing/2014/main" id="{36910EC1-83CF-4D0D-BDEB-2D9B144A36FC}"/>
+                <a16:creationId xmlns:a16="http://schemas.microsoft.com/office/drawing/2014/main" id="{541DDA75-DA7C-4F94-ACF4-EE38F9810C3A}"/>
               </a:ext>
             </a:extLst>
           </p:cNvPr>
@@ -5854,7 +5854,7 @@
                 <a:ea typeface="Georgia"/>
                 <a:cs typeface="Georgia"/>
               </a:rPr>
-              <a:t>Built for a real release</a:t>
+              <a:t>Live web app. Native preview.</a:t>
             </a:r>
           </a:p>
         </p:txBody>
@@ -5864,7 +5864,7 @@
           <p:cNvPr id="4" name="">
             <a:extLst xmlns:a="http://schemas.openxmlformats.org/drawingml/2006/main">
               <a:ext uri="{FF2B5EF4-FFF2-40B4-BE49-F238E27FC236}">
-                <a16:creationId xmlns:a16="http://schemas.microsoft.com/office/drawing/2014/main" id="{F9E05BF1-D838-4C9F-8710-62F43DD1FF2E}"/>
+                <a16:creationId xmlns:a16="http://schemas.microsoft.com/office/drawing/2014/main" id="{64D8E3E8-96DD-480D-ADA3-D243745519B6}"/>
               </a:ext>
             </a:extLst>
           </p:cNvPr>
@@ -5911,7 +5911,7 @@
                 <a:ea typeface="DM Sans"/>
                 <a:cs typeface="DM Sans"/>
               </a:rPr>
-              <a:t>IMPLEMENTATION</a:t>
+              <a:t>VERIFIED TODAY</a:t>
             </a:r>
           </a:p>
         </p:txBody>
@@ -5921,7 +5921,7 @@
           <p:cNvPr id="5" name="">
             <a:extLst xmlns:a="http://schemas.openxmlformats.org/drawingml/2006/main">
               <a:ext uri="{FF2B5EF4-FFF2-40B4-BE49-F238E27FC236}">
-                <a16:creationId xmlns:a16="http://schemas.microsoft.com/office/drawing/2014/main" id="{90F45528-FCEC-4B25-A87E-C64BE1F9842D}"/>
+                <a16:creationId xmlns:a16="http://schemas.microsoft.com/office/drawing/2014/main" id="{756B0C1A-64E9-4941-AF72-8225D27FB9D9}"/>
               </a:ext>
             </a:extLst>
           </p:cNvPr>
@@ -5954,7 +5954,7 @@
                 <a:spcPct val="125000"/>
               </a:lnSpc>
               <a:buNone/>
-              <a:defRPr sz="2100">
+              <a:defRPr sz="2025">
                 <a:solidFill>
                   <a:srgbClr val="252638"/>
                 </a:solidFill>
@@ -5964,7 +5964,7 @@
               </a:defRPr>
             </a:pPr>
             <a:r>
-              <a:rPr sz="2100">
+              <a:rPr sz="2025">
                 <a:solidFill>
                   <a:srgbClr val="252638"/>
                 </a:solidFill>
@@ -5972,7 +5972,7 @@
                 <a:ea typeface="DM Sans"/>
                 <a:cs typeface="DM Sans"/>
               </a:rPr>
-              <a:t>React Native + Expo</a:t>
+              <a:t>Live web app + Android preview</a:t>
             </a:r>
           </a:p>
           <a:p xmlns:a="http://schemas.openxmlformats.org/drawingml/2006/main">
@@ -5981,7 +5981,7 @@
                 <a:spcPct val="125000"/>
               </a:lnSpc>
               <a:buNone/>
-              <a:defRPr sz="2100">
+              <a:defRPr sz="2025">
                 <a:solidFill>
                   <a:srgbClr val="252638"/>
                 </a:solidFill>
@@ -5991,7 +5991,7 @@
               </a:defRPr>
             </a:pPr>
             <a:r>
-              <a:rPr sz="2100">
+              <a:rPr sz="2025">
                 <a:solidFill>
                   <a:srgbClr val="252638"/>
                 </a:solidFill>
@@ -5999,7 +5999,7 @@
                 <a:ea typeface="DM Sans"/>
                 <a:cs typeface="DM Sans"/>
               </a:rPr>
-              <a:t>Local handoffs and history</a:t>
+              <a:t>Firebase account lifecycle</a:t>
             </a:r>
           </a:p>
           <a:p xmlns:a="http://schemas.openxmlformats.org/drawingml/2006/main">
@@ -6008,7 +6008,7 @@
                 <a:spcPct val="125000"/>
               </a:lnSpc>
               <a:buNone/>
-              <a:defRPr sz="2100">
+              <a:defRPr sz="2025">
                 <a:solidFill>
                   <a:srgbClr val="252638"/>
                 </a:solidFill>
@@ -6018,7 +6018,7 @@
               </a:defRPr>
             </a:pPr>
             <a:r>
-              <a:rPr sz="2100">
+              <a:rPr sz="2025">
                 <a:solidFill>
                   <a:srgbClr val="252638"/>
                 </a:solidFill>
@@ -6026,7 +6026,7 @@
                 <a:ea typeface="DM Sans"/>
                 <a:cs typeface="DM Sans"/>
               </a:rPr>
-              <a:t>Validated backup import</a:t>
+              <a:t>101 unit + 30 browser tests</a:t>
             </a:r>
           </a:p>
           <a:p xmlns:a="http://schemas.openxmlformats.org/drawingml/2006/main">
@@ -6035,7 +6035,7 @@
                 <a:spcPct val="125000"/>
               </a:lnSpc>
               <a:buNone/>
-              <a:defRPr sz="2100">
+              <a:defRPr sz="2025">
                 <a:solidFill>
                   <a:srgbClr val="252638"/>
                 </a:solidFill>
@@ -6045,7 +6045,7 @@
               </a:defRPr>
             </a:pPr>
             <a:r>
-              <a:rPr sz="2100">
+              <a:rPr sz="2025">
                 <a:solidFill>
                   <a:srgbClr val="252638"/>
                 </a:solidFill>
@@ -6053,7 +6053,7 @@
                 <a:ea typeface="DM Sans"/>
                 <a:cs typeface="DM Sans"/>
               </a:rPr>
-              <a:t>RevenueCat lifetime integration</a:t>
+              <a:t>Local projects + portable backups</a:t>
             </a:r>
           </a:p>
         </p:txBody>
@@ -6063,7 +6063,7 @@
           <p:cNvPr id="6" name="">
             <a:extLst xmlns:a="http://schemas.openxmlformats.org/drawingml/2006/main">
               <a:ext uri="{FF2B5EF4-FFF2-40B4-BE49-F238E27FC236}">
-                <a16:creationId xmlns:a16="http://schemas.microsoft.com/office/drawing/2014/main" id="{2889DFCE-98A1-4953-8493-918496CE90FC}"/>
+                <a16:creationId xmlns:a16="http://schemas.microsoft.com/office/drawing/2014/main" id="{D9B72EDF-2572-460B-BC35-00803CD45BC8}"/>
               </a:ext>
             </a:extLst>
           </p:cNvPr>
@@ -6120,7 +6120,7 @@
           <p:cNvPr id="7" name="">
             <a:extLst xmlns:a="http://schemas.openxmlformats.org/drawingml/2006/main">
               <a:ext uri="{FF2B5EF4-FFF2-40B4-BE49-F238E27FC236}">
-                <a16:creationId xmlns:a16="http://schemas.microsoft.com/office/drawing/2014/main" id="{56205424-1844-455E-B484-D9B147E74F84}"/>
+                <a16:creationId xmlns:a16="http://schemas.microsoft.com/office/drawing/2014/main" id="{DC7BC673-AEB8-4C39-B21E-9661BA706EE5}"/>
               </a:ext>
             </a:extLst>
           </p:cNvPr>
@@ -6153,7 +6153,7 @@
                 <a:spcPct val="125000"/>
               </a:lnSpc>
               <a:buNone/>
-              <a:defRPr sz="2100">
+              <a:defRPr sz="2025">
                 <a:solidFill>
                   <a:srgbClr val="252638"/>
                 </a:solidFill>
@@ -6163,7 +6163,7 @@
               </a:defRPr>
             </a:pPr>
             <a:r>
-              <a:rPr sz="2100">
+              <a:rPr sz="2025">
                 <a:solidFill>
                   <a:srgbClr val="252638"/>
                 </a:solidFill>
@@ -6171,7 +6171,7 @@
                 <a:ea typeface="DM Sans"/>
                 <a:cs typeface="DM Sans"/>
               </a:rPr>
-              <a:t>Seller and product configuration</a:t>
+              <a:t>Live RevenueCat purchases</a:t>
             </a:r>
           </a:p>
           <a:p xmlns:a="http://schemas.openxmlformats.org/drawingml/2006/main">
@@ -6180,7 +6180,7 @@
                 <a:spcPct val="125000"/>
               </a:lnSpc>
               <a:buNone/>
-              <a:defRPr sz="2100">
+              <a:defRPr sz="2025">
                 <a:solidFill>
                   <a:srgbClr val="252638"/>
                 </a:solidFill>
@@ -6190,7 +6190,7 @@
               </a:defRPr>
             </a:pPr>
             <a:r>
-              <a:rPr sz="2100">
+              <a:rPr sz="2025">
                 <a:solidFill>
                   <a:srgbClr val="252638"/>
                 </a:solidFill>
@@ -6198,7 +6198,7 @@
                 <a:ea typeface="DM Sans"/>
                 <a:cs typeface="DM Sans"/>
               </a:rPr>
-              <a:t>Real Galaxy purchase testing</a:t>
+              <a:t>Purchase-data deletion backend</a:t>
             </a:r>
           </a:p>
           <a:p xmlns:a="http://schemas.openxmlformats.org/drawingml/2006/main">
@@ -6207,7 +6207,7 @@
                 <a:spcPct val="125000"/>
               </a:lnSpc>
               <a:buNone/>
-              <a:defRPr sz="2100">
+              <a:defRPr sz="2025">
                 <a:solidFill>
                   <a:srgbClr val="252638"/>
                 </a:solidFill>
@@ -6217,7 +6217,7 @@
               </a:defRPr>
             </a:pPr>
             <a:r>
-              <a:rPr sz="2100">
+              <a:rPr sz="2025">
                 <a:solidFill>
                   <a:srgbClr val="252638"/>
                 </a:solidFill>
@@ -6225,7 +6225,7 @@
                 <a:ea typeface="DM Sans"/>
                 <a:cs typeface="DM Sans"/>
               </a:rPr>
-              <a:t>Signing and store approval</a:t>
+              <a:t>Physical Galaxy verification</a:t>
             </a:r>
           </a:p>
           <a:p xmlns:a="http://schemas.openxmlformats.org/drawingml/2006/main">
@@ -6234,7 +6234,7 @@
                 <a:spcPct val="125000"/>
               </a:lnSpc>
               <a:buNone/>
-              <a:defRPr sz="2100">
+              <a:defRPr sz="2025">
                 <a:solidFill>
                   <a:srgbClr val="252638"/>
                 </a:solidFill>
@@ -6244,7 +6244,7 @@
               </a:defRPr>
             </a:pPr>
             <a:r>
-              <a:rPr sz="2100">
+              <a:rPr sz="2025">
                 <a:solidFill>
                   <a:srgbClr val="252638"/>
                 </a:solidFill>
@@ -6252,7 +6252,7 @@
                 <a:ea typeface="DM Sans"/>
                 <a:cs typeface="DM Sans"/>
               </a:rPr>
-              <a:t>Device recording and submission</a:t>
+              <a:t>Signed release + store approval</a:t>
             </a:r>
           </a:p>
         </p:txBody>
@@ -6262,19 +6262,19 @@
           <p:cNvPr id="8" name="">
             <a:extLst xmlns:a="http://schemas.openxmlformats.org/drawingml/2006/main">
               <a:ext uri="{FF2B5EF4-FFF2-40B4-BE49-F238E27FC236}">
-                <a16:creationId xmlns:a16="http://schemas.microsoft.com/office/drawing/2014/main" id="{05F98C61-9F52-440D-8DD1-4E75BA7D2C4E}"/>
-              </a:ext>
-            </a:extLst>
-          </p:cNvPr>
-          <p:cNvSpPr>
-            <a:spLocks xmlns:a="http://schemas.openxmlformats.org/drawingml/2006/main" noGrp="1"/>
-          </p:cNvSpPr>
-          <p:nvPr/>
-        </p:nvSpPr>
-        <p:spPr>
-          <a:xfrm xmlns:a="http://schemas.openxmlformats.org/drawingml/2006/main">
-            <a:off x="685800" y="5505450"/>
-            <a:ext cx="10744200" cy="685800"/>
+                <a16:creationId xmlns:a16="http://schemas.microsoft.com/office/drawing/2014/main" id="{837BCCEC-0272-486C-BFBB-67A17E397590}"/>
+              </a:ext>
+            </a:extLst>
+          </p:cNvPr>
+          <p:cNvSpPr>
+            <a:spLocks xmlns:a="http://schemas.openxmlformats.org/drawingml/2006/main" noGrp="1"/>
+          </p:cNvSpPr>
+          <p:nvPr/>
+        </p:nvSpPr>
+        <p:spPr>
+          <a:xfrm xmlns:a="http://schemas.openxmlformats.org/drawingml/2006/main">
+            <a:off x="685800" y="5362575"/>
+            <a:ext cx="10744200" cy="361950"/>
           </a:xfrm>
           <a:prstGeom xmlns:a="http://schemas.openxmlformats.org/drawingml/2006/main" prst="rect">
             <a:avLst/>
@@ -6291,25 +6291,82 @@
           <a:lstStyle xmlns:a="http://schemas.openxmlformats.org/drawingml/2006/main"/>
           <a:p xmlns:a="http://schemas.openxmlformats.org/drawingml/2006/main">
             <a:pPr>
-              <a:defRPr sz="2250">
-                <a:solidFill>
-                  <a:srgbClr val="252638"/>
-                </a:solidFill>
-                <a:latin typeface="Georgia"/>
-                <a:ea typeface="Georgia"/>
-                <a:cs typeface="Georgia"/>
-              </a:defRPr>
-            </a:pPr>
-            <a:r>
-              <a:rPr sz="2250">
-                <a:solidFill>
-                  <a:srgbClr val="252638"/>
-                </a:solidFill>
-                <a:latin typeface="Georgia"/>
-                <a:ea typeface="Georgia"/>
-                <a:cs typeface="Georgia"/>
-              </a:rPr>
-              <a:t>Next proof: a maker returns to their own project because the handoff helped.</a:t>
+              <a:defRPr sz="1875">
+                <a:solidFill>
+                  <a:srgbClr val="5753A3"/>
+                </a:solidFill>
+                <a:latin typeface="DM Sans"/>
+                <a:ea typeface="DM Sans"/>
+                <a:cs typeface="DM Sans"/>
+              </a:defRPr>
+            </a:pPr>
+            <a:r>
+              <a:rPr sz="1875">
+                <a:solidFill>
+                  <a:srgbClr val="5753A3"/>
+                </a:solidFill>
+                <a:latin typeface="DM Sans"/>
+                <a:ea typeface="DM Sans"/>
+                <a:cs typeface="DM Sans"/>
+              </a:rPr>
+              <a:t>Try: https://unpause-studio.web.app</a:t>
+            </a:r>
+          </a:p>
+        </p:txBody>
+      </p:sp>
+      <p:sp>
+        <p:nvSpPr>
+          <p:cNvPr id="9" name="">
+            <a:extLst xmlns:a="http://schemas.openxmlformats.org/drawingml/2006/main">
+              <a:ext uri="{FF2B5EF4-FFF2-40B4-BE49-F238E27FC236}">
+                <a16:creationId xmlns:a16="http://schemas.microsoft.com/office/drawing/2014/main" id="{55668DF2-4B06-44E6-88C3-B5C9CD7008CA}"/>
+              </a:ext>
+            </a:extLst>
+          </p:cNvPr>
+          <p:cNvSpPr>
+            <a:spLocks xmlns:a="http://schemas.openxmlformats.org/drawingml/2006/main" noGrp="1"/>
+          </p:cNvSpPr>
+          <p:nvPr/>
+        </p:nvSpPr>
+        <p:spPr>
+          <a:xfrm xmlns:a="http://schemas.openxmlformats.org/drawingml/2006/main">
+            <a:off x="685800" y="5810250"/>
+            <a:ext cx="10744200" cy="361950"/>
+          </a:xfrm>
+          <a:prstGeom xmlns:a="http://schemas.openxmlformats.org/drawingml/2006/main" prst="rect">
+            <a:avLst/>
+          </a:prstGeom>
+          <a:noFill xmlns:a="http://schemas.openxmlformats.org/drawingml/2006/main"/>
+          <a:ln xmlns:a="http://schemas.openxmlformats.org/drawingml/2006/main" w="0">
+            <a:noFill/>
+          </a:ln>
+        </p:spPr>
+        <p:txBody>
+          <a:bodyPr xmlns:a="http://schemas.openxmlformats.org/drawingml/2006/main" lIns="0" tIns="0" rIns="0" bIns="0">
+            <a:noAutofit/>
+          </a:bodyPr>
+          <a:lstStyle xmlns:a="http://schemas.openxmlformats.org/drawingml/2006/main"/>
+          <a:p xmlns:a="http://schemas.openxmlformats.org/drawingml/2006/main">
+            <a:pPr>
+              <a:defRPr sz="1725">
+                <a:solidFill>
+                  <a:srgbClr val="5753A3"/>
+                </a:solidFill>
+                <a:latin typeface="DM Sans"/>
+                <a:ea typeface="DM Sans"/>
+                <a:cs typeface="DM Sans"/>
+              </a:defRPr>
+            </a:pPr>
+            <a:r>
+              <a:rPr sz="1725">
+                <a:solidFill>
+                  <a:srgbClr val="5753A3"/>
+                </a:solidFill>
+                <a:latin typeface="DM Sans"/>
+                <a:ea typeface="DM Sans"/>
+                <a:cs typeface="DM Sans"/>
+              </a:rPr>
+              <a:t>Watch: https://www.youtube.com/watch?v=jXpOlvDShRY</a:t>
             </a:r>
           </a:p>
         </p:txBody>
@@ -6317,7 +6374,7 @@
     </p:spTree>
     <p:extLst>
       <p:ext uri="{BB962C8B-B14F-4D97-AF65-F5344CB8AC3E}">
-        <p14:creationId xmlns:p14="http://schemas.microsoft.com/office/powerpoint/2010/main" val="1604130295"/>
+        <p14:creationId xmlns:p14="http://schemas.microsoft.com/office/powerpoint/2010/main" val="1739957109"/>
       </p:ext>
     </p:extLst>
   </p:cSld>

</xml_diff>

<commit_message>
Record submitted Devpost entry and verified preview release evidence
</commit_message>
<xml_diff>
--- a/artifacts/submission/Unpause-pitch-final.pptx
+++ b/artifacts/submission/Unpause-pitch-final.pptx
@@ -2,19 +2,19 @@
 <file path=ppt/presentation.xml><?xml version="1.0" encoding="utf-8"?>
 <p:presentation xmlns:p="http://schemas.openxmlformats.org/presentationml/2006/main">
   <p:sldMasterIdLst>
-    <p:sldMasterId xmlns:r="http://schemas.openxmlformats.org/officeDocument/2006/relationships" id="2147483648" r:id="R3402d1789b944f4e"/>
+    <p:sldMasterId xmlns:r="http://schemas.openxmlformats.org/officeDocument/2006/relationships" id="2147483648" r:id="Rd2f98b03e3714df9"/>
   </p:sldMasterIdLst>
   <p:notesMasterIdLst>
-    <p:notesMasterId xmlns:r="http://schemas.openxmlformats.org/officeDocument/2006/relationships" r:id="Raaa602c0cb294047"/>
+    <p:notesMasterId xmlns:r="http://schemas.openxmlformats.org/officeDocument/2006/relationships" r:id="R790f41494a0c4d6e"/>
   </p:notesMasterIdLst>
   <p:sldIdLst>
-    <p:sldId xmlns:r="http://schemas.openxmlformats.org/officeDocument/2006/relationships" id="256" r:id="R48ee015254024529"/>
-    <p:sldId xmlns:r="http://schemas.openxmlformats.org/officeDocument/2006/relationships" id="257" r:id="R030e4e5d3b1f423b"/>
-    <p:sldId xmlns:r="http://schemas.openxmlformats.org/officeDocument/2006/relationships" id="258" r:id="Rec804b5535eb4c04"/>
-    <p:sldId xmlns:r="http://schemas.openxmlformats.org/officeDocument/2006/relationships" id="259" r:id="Raf0db12258e24d0c"/>
-    <p:sldId xmlns:r="http://schemas.openxmlformats.org/officeDocument/2006/relationships" id="260" r:id="Re9d709973cba4308"/>
-    <p:sldId xmlns:r="http://schemas.openxmlformats.org/officeDocument/2006/relationships" id="261" r:id="Rb62e4af325d04851"/>
-    <p:sldId xmlns:r="http://schemas.openxmlformats.org/officeDocument/2006/relationships" id="262" r:id="R2d0aa37404314630"/>
+    <p:sldId xmlns:r="http://schemas.openxmlformats.org/officeDocument/2006/relationships" id="256" r:id="R6cc2dfa8c683411e"/>
+    <p:sldId xmlns:r="http://schemas.openxmlformats.org/officeDocument/2006/relationships" id="257" r:id="R999f62f737d74299"/>
+    <p:sldId xmlns:r="http://schemas.openxmlformats.org/officeDocument/2006/relationships" id="258" r:id="Rfa8ebb804e064f66"/>
+    <p:sldId xmlns:r="http://schemas.openxmlformats.org/officeDocument/2006/relationships" id="259" r:id="Ra8d69b9445924de0"/>
+    <p:sldId xmlns:r="http://schemas.openxmlformats.org/officeDocument/2006/relationships" id="260" r:id="R9644bceaec054c5f"/>
+    <p:sldId xmlns:r="http://schemas.openxmlformats.org/officeDocument/2006/relationships" id="261" r:id="R0f56732a23dc4ab0"/>
+    <p:sldId xmlns:r="http://schemas.openxmlformats.org/officeDocument/2006/relationships" id="262" r:id="Rd1092cf4c1f1406d"/>
   </p:sldIdLst>
   <p:sldSz cx="12192000" cy="6858000"/>
   <p:notesSz cx="6858000" cy="9144000"/>
@@ -658,7 +658,7 @@
           <a:lstStyle xmlns:a="http://schemas.openxmlformats.org/drawingml/2006/main"/>
           <a:p xmlns:a="http://schemas.openxmlformats.org/drawingml/2006/main">
             <a:r>
-              <a:t>Product mechanics: suggestProjects filters by next-step duration and energy, excludes finished projects, and ranks blockers after ready work. Checkpoint history stores context and cumulative session minutes. The core browser and native emulator loop is verified. Current automated checks: 101 unit tests and 30 desktop/mobile browser scenarios. Final physical-device behavior remains a release check.</a:t>
+              <a:t>Product mechanics: suggestProjects filters by next-step duration and energy, excludes finished projects, and ranks blockers after ready work. Checkpoint history stores context and cumulative session minutes. The core browser and native emulator loop is verified. Current automated checks: 154 unit tests and 30 desktop/mobile browser scenarios. Final physical-device behavior remains a release check.</a:t>
             </a:r>
           </a:p>
         </p:txBody>
@@ -868,7 +868,7 @@
           <a:lstStyle xmlns:a="http://schemas.openxmlformats.org/drawingml/2006/main"/>
           <a:p xmlns:a="http://schemas.openxmlformats.org/drawingml/2006/main">
             <a:r>
-              <a:t>Status snapshot September 16, 2026. The public web app is live at https://unpause-studio.web.app . Public narrated Android emulator demo: https://www.youtube.com/watch?v=jXpOlvDShRY . Real hosted Firebase signup, reload persistence, sign-out, sign-in, account deletion, and rejection after deletion passed. Local projects survive account deletion. Firebase is primary, with Supabase a configurable fallback. Accounts do not synchronize projects. 101 unit tests and 30 browser scenarios pass. Android preview exists. iOS source and bundle configuration are prepared but no compiled iOS binary is claimed. Native physical-device auth persistence and password-reset email delivery still need acceptance evidence. No customer traction claimed. Galaxy publication requires real account approval, physical-device billing test, purchase-profile deletion backend, and public store release. Official event rules: https://revenuecat-shipaton-2026.devpost.com/rules . Release gates documented in docs/release/launch-checklist.md.</a:t>
+              <a:t>Status snapshot September 16, 2026. The public web app is live at https://unpause-studio.web.app . Public narrated Android emulator demo: https://www.youtube.com/watch?v=jXpOlvDShRY . Real hosted Firebase signup, reload persistence, sign-out, sign-in, account deletion, and rejection after deletion passed. Local projects survive account deletion. Firebase is primary, with Supabase a configurable fallback. Accounts do not synchronize projects. 154 unit tests and 30 browser scenarios pass. Android preview exists. iOS source and bundle configuration are prepared but no compiled iOS binary is claimed. Native physical-device auth persistence and password-reset email delivery still need acceptance evidence. RevenueCat project projb008cb09 has configured Galaxy, iOS, Google Play and Test Store mappings for studio/default/$rc_lifetime/unpause_studio_lifetime. Actual native Test Store cancellation, failure, success, restoration, and cold restart passed. These are simulated transactions, not production revenue. Supabase hosts the live Firebase/RevenueCat coordinated deletion service; all 15 live checks passed, including stale authentication, safe replay and rate limits, with four disposable identities cleaned. Samsung registration is complete, but Android app registration is blocked on Corporate Commercial Distribution Seller approval. Devpost entry submitted: https://devpost.com/software/unpause-k9p21y . No qualifying store release or customer traction is claimed. Galaxy publication still needs seller approval, physical store-device billing verification, production signing, and store approval. Official event rules: https://revenuecat-shipaton-2026.devpost.com/rules . Release gates documented in docs/release/launch-checklist.md.</a:t>
             </a:r>
           </a:p>
         </p:txBody>
@@ -936,7 +936,7 @@
   </p:cSld>
   <p:clrMap bg1="lt1" tx1="dk1" bg2="lt2" tx2="dk2" accent1="accent1" accent2="accent2" accent3="accent3" accent4="accent4" accent5="accent5" accent6="accent6" hlink="hlink" folHlink="folHlink"/>
   <p:sldLayoutIdLst>
-    <p:sldLayoutId xmlns:r="http://schemas.openxmlformats.org/officeDocument/2006/relationships" id="2147483649" r:id="Re73cbdbb10974a3d"/>
+    <p:sldLayoutId xmlns:r="http://schemas.openxmlformats.org/officeDocument/2006/relationships" id="2147483649" r:id="R1fc76dde724e4da0"/>
   </p:sldLayoutIdLst>
   <p:txStyles>
     <p:titleStyle>
@@ -1487,7 +1487,7 @@
           <p:cNvPr id="10" name="">
             <a:extLst xmlns:a="http://schemas.openxmlformats.org/drawingml/2006/main">
               <a:ext uri="{FF2B5EF4-FFF2-40B4-BE49-F238E27FC236}">
-                <a16:creationId xmlns:a16="http://schemas.microsoft.com/office/drawing/2014/main" id="{C982C179-3A1F-4509-A793-EB4AA9514749}"/>
+                <a16:creationId xmlns:a16="http://schemas.microsoft.com/office/drawing/2014/main" id="{8F73AC07-806A-400C-8875-57BD702CE89A}"/>
               </a:ext>
             </a:extLst>
           </p:cNvPr>
@@ -1544,7 +1544,7 @@
           <p:cNvPr id="2" name="">
             <a:extLst xmlns:a="http://schemas.openxmlformats.org/drawingml/2006/main">
               <a:ext uri="{FF2B5EF4-FFF2-40B4-BE49-F238E27FC236}">
-                <a16:creationId xmlns:a16="http://schemas.microsoft.com/office/drawing/2014/main" id="{F4EC87CC-4B63-4C12-8338-F8342D8B7963}"/>
+                <a16:creationId xmlns:a16="http://schemas.microsoft.com/office/drawing/2014/main" id="{247074FB-8413-4F80-977E-5A00DF3E6E59}"/>
               </a:ext>
             </a:extLst>
           </p:cNvPr>
@@ -1601,7 +1601,7 @@
           <p:cNvPr id="3" name="">
             <a:extLst xmlns:a="http://schemas.openxmlformats.org/drawingml/2006/main">
               <a:ext uri="{FF2B5EF4-FFF2-40B4-BE49-F238E27FC236}">
-                <a16:creationId xmlns:a16="http://schemas.microsoft.com/office/drawing/2014/main" id="{8A1590AA-73E2-4964-829E-45FABCECB2F4}"/>
+                <a16:creationId xmlns:a16="http://schemas.microsoft.com/office/drawing/2014/main" id="{0D6A14C4-3EE3-4D30-AFD6-2B87D4181ADC}"/>
               </a:ext>
             </a:extLst>
           </p:cNvPr>
@@ -1631,7 +1631,7 @@
           <p:cNvPr id="4" name="">
             <a:extLst xmlns:a="http://schemas.openxmlformats.org/drawingml/2006/main">
               <a:ext uri="{FF2B5EF4-FFF2-40B4-BE49-F238E27FC236}">
-                <a16:creationId xmlns:a16="http://schemas.microsoft.com/office/drawing/2014/main" id="{4FB0A1B4-72C2-4DCF-B962-979D28A9A63C}"/>
+                <a16:creationId xmlns:a16="http://schemas.microsoft.com/office/drawing/2014/main" id="{067CA4B3-91BF-4C04-A469-6AC7536E4ED8}"/>
               </a:ext>
             </a:extLst>
           </p:cNvPr>
@@ -1661,7 +1661,7 @@
           <p:cNvPr id="5" name="">
             <a:extLst xmlns:a="http://schemas.openxmlformats.org/drawingml/2006/main">
               <a:ext uri="{FF2B5EF4-FFF2-40B4-BE49-F238E27FC236}">
-                <a16:creationId xmlns:a16="http://schemas.microsoft.com/office/drawing/2014/main" id="{BC74D646-CF7D-4577-9CB6-57B5EA729302}"/>
+                <a16:creationId xmlns:a16="http://schemas.microsoft.com/office/drawing/2014/main" id="{BEF8D1AF-4155-42D6-9FDC-0AE6113D9B40}"/>
               </a:ext>
             </a:extLst>
           </p:cNvPr>
@@ -1691,7 +1691,7 @@
           <p:cNvPr id="6" name="">
             <a:extLst xmlns:a="http://schemas.openxmlformats.org/drawingml/2006/main">
               <a:ext uri="{FF2B5EF4-FFF2-40B4-BE49-F238E27FC236}">
-                <a16:creationId xmlns:a16="http://schemas.microsoft.com/office/drawing/2014/main" id="{CD419368-9FE1-485B-8E06-D78D5B87B54E}"/>
+                <a16:creationId xmlns:a16="http://schemas.microsoft.com/office/drawing/2014/main" id="{86E6CA9B-5D55-4420-A9AB-E1B0CA2CA482}"/>
               </a:ext>
             </a:extLst>
           </p:cNvPr>
@@ -1748,7 +1748,7 @@
           <p:cNvPr id="7" name="">
             <a:extLst xmlns:a="http://schemas.openxmlformats.org/drawingml/2006/main">
               <a:ext uri="{FF2B5EF4-FFF2-40B4-BE49-F238E27FC236}">
-                <a16:creationId xmlns:a16="http://schemas.microsoft.com/office/drawing/2014/main" id="{16470E4B-9FCC-4E11-B65D-07C0E6409B51}"/>
+                <a16:creationId xmlns:a16="http://schemas.microsoft.com/office/drawing/2014/main" id="{6E886EAB-0CF7-48D7-9659-D1AAFBF254F1}"/>
               </a:ext>
             </a:extLst>
           </p:cNvPr>
@@ -1805,7 +1805,7 @@
           <p:cNvPr id="8" name="">
             <a:extLst xmlns:a="http://schemas.openxmlformats.org/drawingml/2006/main">
               <a:ext uri="{FF2B5EF4-FFF2-40B4-BE49-F238E27FC236}">
-                <a16:creationId xmlns:a16="http://schemas.microsoft.com/office/drawing/2014/main" id="{918A4784-2393-47A5-8174-3D0072969F3E}"/>
+                <a16:creationId xmlns:a16="http://schemas.microsoft.com/office/drawing/2014/main" id="{FFF6919A-B69B-46EB-8E0E-816924B467E7}"/>
               </a:ext>
             </a:extLst>
           </p:cNvPr>
@@ -1862,7 +1862,7 @@
           <p:cNvPr id="9" name="">
             <a:extLst xmlns:a="http://schemas.openxmlformats.org/drawingml/2006/main">
               <a:ext uri="{FF2B5EF4-FFF2-40B4-BE49-F238E27FC236}">
-                <a16:creationId xmlns:a16="http://schemas.microsoft.com/office/drawing/2014/main" id="{4B22037F-8EDB-453A-9C69-E3C999C926F8}"/>
+                <a16:creationId xmlns:a16="http://schemas.microsoft.com/office/drawing/2014/main" id="{AB999622-04BC-4132-8341-114AFB48C6E1}"/>
               </a:ext>
             </a:extLst>
           </p:cNvPr>
@@ -1917,7 +1917,7 @@
     </p:spTree>
     <p:extLst>
       <p:ext uri="{BB962C8B-B14F-4D97-AF65-F5344CB8AC3E}">
-        <p14:creationId xmlns:p14="http://schemas.microsoft.com/office/powerpoint/2010/main" val="1238613018"/>
+        <p14:creationId xmlns:p14="http://schemas.microsoft.com/office/powerpoint/2010/main" val="866110323"/>
       </p:ext>
     </p:extLst>
   </p:cSld>
@@ -1948,7 +1948,7 @@
           <p:cNvPr id="8" name="">
             <a:extLst xmlns:a="http://schemas.openxmlformats.org/drawingml/2006/main">
               <a:ext uri="{FF2B5EF4-FFF2-40B4-BE49-F238E27FC236}">
-                <a16:creationId xmlns:a16="http://schemas.microsoft.com/office/drawing/2014/main" id="{F5D6A8BD-EBD5-48C9-BB72-D3DEC68C5217}"/>
+                <a16:creationId xmlns:a16="http://schemas.microsoft.com/office/drawing/2014/main" id="{CF7DB8C5-D859-4425-BD31-95AA6AB64A46}"/>
               </a:ext>
             </a:extLst>
           </p:cNvPr>
@@ -2005,7 +2005,7 @@
           <p:cNvPr id="2" name="">
             <a:extLst xmlns:a="http://schemas.openxmlformats.org/drawingml/2006/main">
               <a:ext uri="{FF2B5EF4-FFF2-40B4-BE49-F238E27FC236}">
-                <a16:creationId xmlns:a16="http://schemas.microsoft.com/office/drawing/2014/main" id="{044E5565-215C-4A3E-8FA7-9D5FE97C497D}"/>
+                <a16:creationId xmlns:a16="http://schemas.microsoft.com/office/drawing/2014/main" id="{DA4179F8-B199-4281-909E-560225462F68}"/>
               </a:ext>
             </a:extLst>
           </p:cNvPr>
@@ -2062,7 +2062,7 @@
           <p:cNvPr id="3" name="">
             <a:extLst xmlns:a="http://schemas.openxmlformats.org/drawingml/2006/main">
               <a:ext uri="{FF2B5EF4-FFF2-40B4-BE49-F238E27FC236}">
-                <a16:creationId xmlns:a16="http://schemas.microsoft.com/office/drawing/2014/main" id="{98064D36-6310-44D8-95EF-0EFEF58F7537}"/>
+                <a16:creationId xmlns:a16="http://schemas.microsoft.com/office/drawing/2014/main" id="{2B948DF7-AC60-452A-A5E0-467A38175067}"/>
               </a:ext>
             </a:extLst>
           </p:cNvPr>
@@ -2142,7 +2142,7 @@
           <p:cNvPr id="4" name="">
             <a:extLst xmlns:a="http://schemas.openxmlformats.org/drawingml/2006/main">
               <a:ext uri="{FF2B5EF4-FFF2-40B4-BE49-F238E27FC236}">
-                <a16:creationId xmlns:a16="http://schemas.microsoft.com/office/drawing/2014/main" id="{5A898121-8E49-4230-B04F-C17EBE37BB30}"/>
+                <a16:creationId xmlns:a16="http://schemas.microsoft.com/office/drawing/2014/main" id="{F5604F42-C332-497D-BACC-14322860E77C}"/>
               </a:ext>
             </a:extLst>
           </p:cNvPr>
@@ -2199,7 +2199,7 @@
           <p:cNvPr id="5" name="">
             <a:extLst xmlns:a="http://schemas.openxmlformats.org/drawingml/2006/main">
               <a:ext uri="{FF2B5EF4-FFF2-40B4-BE49-F238E27FC236}">
-                <a16:creationId xmlns:a16="http://schemas.microsoft.com/office/drawing/2014/main" id="{443BDB5B-A5F3-47A7-93A4-B0C1F1D88A84}"/>
+                <a16:creationId xmlns:a16="http://schemas.microsoft.com/office/drawing/2014/main" id="{91B982F4-E41C-4865-B12D-CF8C0A8DEC8B}"/>
               </a:ext>
             </a:extLst>
           </p:cNvPr>
@@ -2256,7 +2256,7 @@
           <p:cNvPr id="6" name="">
             <a:extLst xmlns:a="http://schemas.openxmlformats.org/drawingml/2006/main">
               <a:ext uri="{FF2B5EF4-FFF2-40B4-BE49-F238E27FC236}">
-                <a16:creationId xmlns:a16="http://schemas.microsoft.com/office/drawing/2014/main" id="{61BEEBD4-C570-4774-9F87-3A09BB3FF670}"/>
+                <a16:creationId xmlns:a16="http://schemas.microsoft.com/office/drawing/2014/main" id="{A24B6256-132D-4976-9E9D-CB112001FCBD}"/>
               </a:ext>
             </a:extLst>
           </p:cNvPr>
@@ -2371,7 +2371,7 @@
           <p:cNvPr id="7" name="">
             <a:extLst xmlns:a="http://schemas.openxmlformats.org/drawingml/2006/main">
               <a:ext uri="{FF2B5EF4-FFF2-40B4-BE49-F238E27FC236}">
-                <a16:creationId xmlns:a16="http://schemas.microsoft.com/office/drawing/2014/main" id="{AF2FBA3D-4E53-4193-8442-AD0054437EF6}"/>
+                <a16:creationId xmlns:a16="http://schemas.microsoft.com/office/drawing/2014/main" id="{C5457059-A865-486D-9747-D531097E1CBD}"/>
               </a:ext>
             </a:extLst>
           </p:cNvPr>
@@ -2426,7 +2426,7 @@
     </p:spTree>
     <p:extLst>
       <p:ext uri="{BB962C8B-B14F-4D97-AF65-F5344CB8AC3E}">
-        <p14:creationId xmlns:p14="http://schemas.microsoft.com/office/powerpoint/2010/main" val="786054344"/>
+        <p14:creationId xmlns:p14="http://schemas.microsoft.com/office/powerpoint/2010/main" val="365864374"/>
       </p:ext>
     </p:extLst>
   </p:cSld>
@@ -2457,7 +2457,7 @@
           <p:cNvPr id="16" name="">
             <a:extLst xmlns:a="http://schemas.openxmlformats.org/drawingml/2006/main">
               <a:ext uri="{FF2B5EF4-FFF2-40B4-BE49-F238E27FC236}">
-                <a16:creationId xmlns:a16="http://schemas.microsoft.com/office/drawing/2014/main" id="{D233F857-F25F-41F2-A1C5-3C936B0670E4}"/>
+                <a16:creationId xmlns:a16="http://schemas.microsoft.com/office/drawing/2014/main" id="{836160B8-AAC0-4446-BE99-B12A56152EEC}"/>
               </a:ext>
             </a:extLst>
           </p:cNvPr>
@@ -2514,7 +2514,7 @@
           <p:cNvPr id="2" name="">
             <a:extLst xmlns:a="http://schemas.openxmlformats.org/drawingml/2006/main">
               <a:ext uri="{FF2B5EF4-FFF2-40B4-BE49-F238E27FC236}">
-                <a16:creationId xmlns:a16="http://schemas.microsoft.com/office/drawing/2014/main" id="{010EF863-5CDB-44B1-AAF6-E57FEDA32432}"/>
+                <a16:creationId xmlns:a16="http://schemas.microsoft.com/office/drawing/2014/main" id="{C8B229F8-BBC9-4306-AD9E-BB054F029CAA}"/>
               </a:ext>
             </a:extLst>
           </p:cNvPr>
@@ -2571,7 +2571,7 @@
           <p:cNvPr id="3" name="">
             <a:extLst xmlns:a="http://schemas.openxmlformats.org/drawingml/2006/main">
               <a:ext uri="{FF2B5EF4-FFF2-40B4-BE49-F238E27FC236}">
-                <a16:creationId xmlns:a16="http://schemas.microsoft.com/office/drawing/2014/main" id="{20D26D12-DC3B-43DE-8B32-82431CDF56AE}"/>
+                <a16:creationId xmlns:a16="http://schemas.microsoft.com/office/drawing/2014/main" id="{588F40F0-530C-4089-BBBF-B2524E687A8E}"/>
               </a:ext>
             </a:extLst>
           </p:cNvPr>
@@ -2628,7 +2628,7 @@
           <p:cNvPr id="4" name="">
             <a:extLst xmlns:a="http://schemas.openxmlformats.org/drawingml/2006/main">
               <a:ext uri="{FF2B5EF4-FFF2-40B4-BE49-F238E27FC236}">
-                <a16:creationId xmlns:a16="http://schemas.microsoft.com/office/drawing/2014/main" id="{2F2570C0-EFED-4DAF-9C21-23B1BECBB1F6}"/>
+                <a16:creationId xmlns:a16="http://schemas.microsoft.com/office/drawing/2014/main" id="{C9593B35-1C7F-4A66-9BB3-CFF8452CD8F7}"/>
               </a:ext>
             </a:extLst>
           </p:cNvPr>
@@ -2716,7 +2716,7 @@
           <p:cNvPr id="5" name="">
             <a:extLst xmlns:a="http://schemas.openxmlformats.org/drawingml/2006/main">
               <a:ext uri="{FF2B5EF4-FFF2-40B4-BE49-F238E27FC236}">
-                <a16:creationId xmlns:a16="http://schemas.microsoft.com/office/drawing/2014/main" id="{678054EE-11C9-41AA-933B-3D8B237541D4}"/>
+                <a16:creationId xmlns:a16="http://schemas.microsoft.com/office/drawing/2014/main" id="{CE2CB714-9F47-48CF-A855-EA7DF4DB9C12}"/>
               </a:ext>
             </a:extLst>
           </p:cNvPr>
@@ -2796,7 +2796,7 @@
           <p:cNvPr id="6" name="">
             <a:extLst xmlns:a="http://schemas.openxmlformats.org/drawingml/2006/main">
               <a:ext uri="{FF2B5EF4-FFF2-40B4-BE49-F238E27FC236}">
-                <a16:creationId xmlns:a16="http://schemas.microsoft.com/office/drawing/2014/main" id="{4459C308-8FA9-4C39-B62D-C63D2E7D9B67}"/>
+                <a16:creationId xmlns:a16="http://schemas.microsoft.com/office/drawing/2014/main" id="{D12A68E6-8ADB-42C5-8319-BFBBA615E63F}"/>
               </a:ext>
             </a:extLst>
           </p:cNvPr>
@@ -2828,7 +2828,7 @@
           <p:cNvPr id="7" name="">
             <a:extLst xmlns:a="http://schemas.openxmlformats.org/drawingml/2006/main">
               <a:ext uri="{FF2B5EF4-FFF2-40B4-BE49-F238E27FC236}">
-                <a16:creationId xmlns:a16="http://schemas.microsoft.com/office/drawing/2014/main" id="{3B03CB09-3F41-4382-BA6F-4BD40C6BE315}"/>
+                <a16:creationId xmlns:a16="http://schemas.microsoft.com/office/drawing/2014/main" id="{3410EADA-43F1-4684-9359-29F9834E5DAC}"/>
               </a:ext>
             </a:extLst>
           </p:cNvPr>
@@ -2858,7 +2858,7 @@
           <p:cNvPr id="8" name="">
             <a:extLst xmlns:a="http://schemas.openxmlformats.org/drawingml/2006/main">
               <a:ext uri="{FF2B5EF4-FFF2-40B4-BE49-F238E27FC236}">
-                <a16:creationId xmlns:a16="http://schemas.microsoft.com/office/drawing/2014/main" id="{D1CA1117-6D9B-4E7C-AAAF-A9C29AF743DE}"/>
+                <a16:creationId xmlns:a16="http://schemas.microsoft.com/office/drawing/2014/main" id="{E285F173-203B-4E60-A668-54BC36882A11}"/>
               </a:ext>
             </a:extLst>
           </p:cNvPr>
@@ -2915,7 +2915,7 @@
           <p:cNvPr id="9" name="">
             <a:extLst xmlns:a="http://schemas.openxmlformats.org/drawingml/2006/main">
               <a:ext uri="{FF2B5EF4-FFF2-40B4-BE49-F238E27FC236}">
-                <a16:creationId xmlns:a16="http://schemas.microsoft.com/office/drawing/2014/main" id="{FBF23565-55E2-4AD6-A832-AC2B5080A2AD}"/>
+                <a16:creationId xmlns:a16="http://schemas.microsoft.com/office/drawing/2014/main" id="{4AAD4983-C4CE-459F-B7F9-E1F645FB0F24}"/>
               </a:ext>
             </a:extLst>
           </p:cNvPr>
@@ -2972,7 +2972,7 @@
           <p:cNvPr id="10" name="">
             <a:extLst xmlns:a="http://schemas.openxmlformats.org/drawingml/2006/main">
               <a:ext uri="{FF2B5EF4-FFF2-40B4-BE49-F238E27FC236}">
-                <a16:creationId xmlns:a16="http://schemas.microsoft.com/office/drawing/2014/main" id="{4B063A3D-D780-40F6-B806-184758684185}"/>
+                <a16:creationId xmlns:a16="http://schemas.microsoft.com/office/drawing/2014/main" id="{110FE63B-E9CB-43DE-B208-9DD665A4991D}"/>
               </a:ext>
             </a:extLst>
           </p:cNvPr>
@@ -3029,7 +3029,7 @@
           <p:cNvPr id="11" name="">
             <a:extLst xmlns:a="http://schemas.openxmlformats.org/drawingml/2006/main">
               <a:ext uri="{FF2B5EF4-FFF2-40B4-BE49-F238E27FC236}">
-                <a16:creationId xmlns:a16="http://schemas.microsoft.com/office/drawing/2014/main" id="{79CAEA50-D586-42D2-95BA-B318C9386E57}"/>
+                <a16:creationId xmlns:a16="http://schemas.microsoft.com/office/drawing/2014/main" id="{6A55CC47-E6A4-4C2F-B95F-C80200DD3E1F}"/>
               </a:ext>
             </a:extLst>
           </p:cNvPr>
@@ -3086,7 +3086,7 @@
           <p:cNvPr id="12" name="">
             <a:extLst xmlns:a="http://schemas.openxmlformats.org/drawingml/2006/main">
               <a:ext uri="{FF2B5EF4-FFF2-40B4-BE49-F238E27FC236}">
-                <a16:creationId xmlns:a16="http://schemas.microsoft.com/office/drawing/2014/main" id="{01EC630D-7344-46EB-B5FF-43A0683008D3}"/>
+                <a16:creationId xmlns:a16="http://schemas.microsoft.com/office/drawing/2014/main" id="{5F8B4506-EB44-44A1-9549-BEAC1F82C597}"/>
               </a:ext>
             </a:extLst>
           </p:cNvPr>
@@ -3166,7 +3166,7 @@
           <p:cNvPr id="13" name="">
             <a:extLst xmlns:a="http://schemas.openxmlformats.org/drawingml/2006/main">
               <a:ext uri="{FF2B5EF4-FFF2-40B4-BE49-F238E27FC236}">
-                <a16:creationId xmlns:a16="http://schemas.microsoft.com/office/drawing/2014/main" id="{C1A3BC76-DEAC-43D5-B89E-B5EB0F7F5D18}"/>
+                <a16:creationId xmlns:a16="http://schemas.microsoft.com/office/drawing/2014/main" id="{9AE52078-1CCA-44FC-A310-64AA81D1631C}"/>
               </a:ext>
             </a:extLst>
           </p:cNvPr>
@@ -3223,7 +3223,7 @@
           <p:cNvPr id="14" name="">
             <a:extLst xmlns:a="http://schemas.openxmlformats.org/drawingml/2006/main">
               <a:ext uri="{FF2B5EF4-FFF2-40B4-BE49-F238E27FC236}">
-                <a16:creationId xmlns:a16="http://schemas.microsoft.com/office/drawing/2014/main" id="{5C9E83F0-B426-47BD-8410-9C1BE7D8B968}"/>
+                <a16:creationId xmlns:a16="http://schemas.microsoft.com/office/drawing/2014/main" id="{492732E0-AEC3-4BD7-80AA-034597F22874}"/>
               </a:ext>
             </a:extLst>
           </p:cNvPr>
@@ -3280,7 +3280,7 @@
           <p:cNvPr id="15" name="">
             <a:extLst xmlns:a="http://schemas.openxmlformats.org/drawingml/2006/main">
               <a:ext uri="{FF2B5EF4-FFF2-40B4-BE49-F238E27FC236}">
-                <a16:creationId xmlns:a16="http://schemas.microsoft.com/office/drawing/2014/main" id="{FA84A153-D43D-48B4-89E6-6D4CAA51F262}"/>
+                <a16:creationId xmlns:a16="http://schemas.microsoft.com/office/drawing/2014/main" id="{9D50C573-5C77-43F3-9C85-130099CF3F60}"/>
               </a:ext>
             </a:extLst>
           </p:cNvPr>
@@ -3335,7 +3335,7 @@
     </p:spTree>
     <p:extLst>
       <p:ext uri="{BB962C8B-B14F-4D97-AF65-F5344CB8AC3E}">
-        <p14:creationId xmlns:p14="http://schemas.microsoft.com/office/powerpoint/2010/main" val="426658300"/>
+        <p14:creationId xmlns:p14="http://schemas.microsoft.com/office/powerpoint/2010/main" val="392334690"/>
       </p:ext>
     </p:extLst>
   </p:cSld>
@@ -3366,7 +3366,7 @@
           <p:cNvPr id="21" name="">
             <a:extLst xmlns:a="http://schemas.openxmlformats.org/drawingml/2006/main">
               <a:ext uri="{FF2B5EF4-FFF2-40B4-BE49-F238E27FC236}">
-                <a16:creationId xmlns:a16="http://schemas.microsoft.com/office/drawing/2014/main" id="{02E8174B-C674-493B-8379-67B82246543B}"/>
+                <a16:creationId xmlns:a16="http://schemas.microsoft.com/office/drawing/2014/main" id="{ED0FCCA5-3775-4AA4-BE40-2F30ACDE89DE}"/>
               </a:ext>
             </a:extLst>
           </p:cNvPr>
@@ -3423,7 +3423,7 @@
           <p:cNvPr id="2" name="">
             <a:extLst xmlns:a="http://schemas.openxmlformats.org/drawingml/2006/main">
               <a:ext uri="{FF2B5EF4-FFF2-40B4-BE49-F238E27FC236}">
-                <a16:creationId xmlns:a16="http://schemas.microsoft.com/office/drawing/2014/main" id="{FFA49EB5-EF83-429F-A7B8-CB98F4F7ABF9}"/>
+                <a16:creationId xmlns:a16="http://schemas.microsoft.com/office/drawing/2014/main" id="{1C41629B-2521-4107-B15D-46CC13485E6A}"/>
               </a:ext>
             </a:extLst>
           </p:cNvPr>
@@ -3480,7 +3480,7 @@
           <p:cNvPr id="3" name="">
             <a:extLst xmlns:a="http://schemas.openxmlformats.org/drawingml/2006/main">
               <a:ext uri="{FF2B5EF4-FFF2-40B4-BE49-F238E27FC236}">
-                <a16:creationId xmlns:a16="http://schemas.microsoft.com/office/drawing/2014/main" id="{0E951D40-00F2-49A3-8DDB-51293829FAE8}"/>
+                <a16:creationId xmlns:a16="http://schemas.microsoft.com/office/drawing/2014/main" id="{418E72D8-72D0-4ABC-AB79-B2F1DA71872E}"/>
               </a:ext>
             </a:extLst>
           </p:cNvPr>
@@ -3537,7 +3537,7 @@
           <p:cNvPr id="4" name="">
             <a:extLst xmlns:a="http://schemas.openxmlformats.org/drawingml/2006/main">
               <a:ext uri="{FF2B5EF4-FFF2-40B4-BE49-F238E27FC236}">
-                <a16:creationId xmlns:a16="http://schemas.microsoft.com/office/drawing/2014/main" id="{4A01BB67-1BD0-4FC1-AFB3-F41FE6730E3E}"/>
+                <a16:creationId xmlns:a16="http://schemas.microsoft.com/office/drawing/2014/main" id="{94649B84-5C23-4895-AA96-270AB9431039}"/>
               </a:ext>
             </a:extLst>
           </p:cNvPr>
@@ -3594,7 +3594,7 @@
           <p:cNvPr id="5" name="">
             <a:extLst xmlns:a="http://schemas.openxmlformats.org/drawingml/2006/main">
               <a:ext uri="{FF2B5EF4-FFF2-40B4-BE49-F238E27FC236}">
-                <a16:creationId xmlns:a16="http://schemas.microsoft.com/office/drawing/2014/main" id="{F9BC91C3-B97C-40B6-A6C0-EC5FFD0B072E}"/>
+                <a16:creationId xmlns:a16="http://schemas.microsoft.com/office/drawing/2014/main" id="{4133A92C-A9D4-45B4-BC75-9E196CB6BEC2}"/>
               </a:ext>
             </a:extLst>
           </p:cNvPr>
@@ -3651,7 +3651,7 @@
           <p:cNvPr id="6" name="">
             <a:extLst xmlns:a="http://schemas.openxmlformats.org/drawingml/2006/main">
               <a:ext uri="{FF2B5EF4-FFF2-40B4-BE49-F238E27FC236}">
-                <a16:creationId xmlns:a16="http://schemas.microsoft.com/office/drawing/2014/main" id="{88F2E3C0-03FA-43BF-9094-221745416C2E}"/>
+                <a16:creationId xmlns:a16="http://schemas.microsoft.com/office/drawing/2014/main" id="{F0633F71-B1C3-4211-A338-5431C2C544BC}"/>
               </a:ext>
             </a:extLst>
           </p:cNvPr>
@@ -3681,7 +3681,7 @@
           <p:cNvPr id="7" name="">
             <a:extLst xmlns:a="http://schemas.openxmlformats.org/drawingml/2006/main">
               <a:ext uri="{FF2B5EF4-FFF2-40B4-BE49-F238E27FC236}">
-                <a16:creationId xmlns:a16="http://schemas.microsoft.com/office/drawing/2014/main" id="{7FDD8247-2FB9-4BC9-8B88-58671C79ACAC}"/>
+                <a16:creationId xmlns:a16="http://schemas.microsoft.com/office/drawing/2014/main" id="{204087E5-A861-4B79-91F9-E4C7F378E6A9}"/>
               </a:ext>
             </a:extLst>
           </p:cNvPr>
@@ -3738,7 +3738,7 @@
           <p:cNvPr id="8" name="">
             <a:extLst xmlns:a="http://schemas.openxmlformats.org/drawingml/2006/main">
               <a:ext uri="{FF2B5EF4-FFF2-40B4-BE49-F238E27FC236}">
-                <a16:creationId xmlns:a16="http://schemas.microsoft.com/office/drawing/2014/main" id="{E09E0DFF-39D0-4E10-952B-502DDB88219F}"/>
+                <a16:creationId xmlns:a16="http://schemas.microsoft.com/office/drawing/2014/main" id="{34E7D632-FF9D-48EF-9114-3A8B5E25EC3F}"/>
               </a:ext>
             </a:extLst>
           </p:cNvPr>
@@ -3818,7 +3818,7 @@
           <p:cNvPr id="9" name="">
             <a:extLst xmlns:a="http://schemas.openxmlformats.org/drawingml/2006/main">
               <a:ext uri="{FF2B5EF4-FFF2-40B4-BE49-F238E27FC236}">
-                <a16:creationId xmlns:a16="http://schemas.microsoft.com/office/drawing/2014/main" id="{759EFBD9-BFF2-4A52-BAA2-FA09C4CCEA78}"/>
+                <a16:creationId xmlns:a16="http://schemas.microsoft.com/office/drawing/2014/main" id="{9503692E-A34C-4C9F-B4FB-649B66BA4D7B}"/>
               </a:ext>
             </a:extLst>
           </p:cNvPr>
@@ -3875,7 +3875,7 @@
           <p:cNvPr id="10" name="">
             <a:extLst xmlns:a="http://schemas.openxmlformats.org/drawingml/2006/main">
               <a:ext uri="{FF2B5EF4-FFF2-40B4-BE49-F238E27FC236}">
-                <a16:creationId xmlns:a16="http://schemas.microsoft.com/office/drawing/2014/main" id="{472FE0FF-066F-49C8-9544-14DE45C10D8A}"/>
+                <a16:creationId xmlns:a16="http://schemas.microsoft.com/office/drawing/2014/main" id="{75F0C404-D02F-4662-961F-77FF676F9059}"/>
               </a:ext>
             </a:extLst>
           </p:cNvPr>
@@ -3905,7 +3905,7 @@
           <p:cNvPr id="11" name="">
             <a:extLst xmlns:a="http://schemas.openxmlformats.org/drawingml/2006/main">
               <a:ext uri="{FF2B5EF4-FFF2-40B4-BE49-F238E27FC236}">
-                <a16:creationId xmlns:a16="http://schemas.microsoft.com/office/drawing/2014/main" id="{45A6A38B-1628-42C5-8124-851D9AC0EB8F}"/>
+                <a16:creationId xmlns:a16="http://schemas.microsoft.com/office/drawing/2014/main" id="{549B4C2B-8857-4141-BF59-BB24EA345A59}"/>
               </a:ext>
             </a:extLst>
           </p:cNvPr>
@@ -3962,7 +3962,7 @@
           <p:cNvPr id="12" name="">
             <a:extLst xmlns:a="http://schemas.openxmlformats.org/drawingml/2006/main">
               <a:ext uri="{FF2B5EF4-FFF2-40B4-BE49-F238E27FC236}">
-                <a16:creationId xmlns:a16="http://schemas.microsoft.com/office/drawing/2014/main" id="{B0B27333-8117-424A-A965-0C2E4F21A536}"/>
+                <a16:creationId xmlns:a16="http://schemas.microsoft.com/office/drawing/2014/main" id="{24788BBB-4237-4393-93CF-B74FF73DAE66}"/>
               </a:ext>
             </a:extLst>
           </p:cNvPr>
@@ -4042,7 +4042,7 @@
           <p:cNvPr id="13" name="">
             <a:extLst xmlns:a="http://schemas.openxmlformats.org/drawingml/2006/main">
               <a:ext uri="{FF2B5EF4-FFF2-40B4-BE49-F238E27FC236}">
-                <a16:creationId xmlns:a16="http://schemas.microsoft.com/office/drawing/2014/main" id="{878D59B6-4D00-4EE2-8D57-352D2593797A}"/>
+                <a16:creationId xmlns:a16="http://schemas.microsoft.com/office/drawing/2014/main" id="{AD2DE005-09E0-42E5-815C-8032B1D5F3D7}"/>
               </a:ext>
             </a:extLst>
           </p:cNvPr>
@@ -4099,7 +4099,7 @@
           <p:cNvPr id="14" name="">
             <a:extLst xmlns:a="http://schemas.openxmlformats.org/drawingml/2006/main">
               <a:ext uri="{FF2B5EF4-FFF2-40B4-BE49-F238E27FC236}">
-                <a16:creationId xmlns:a16="http://schemas.microsoft.com/office/drawing/2014/main" id="{F1E7A77E-3343-48E8-8F44-1FF6189D05AE}"/>
+                <a16:creationId xmlns:a16="http://schemas.microsoft.com/office/drawing/2014/main" id="{313A2F18-640F-462E-8112-755CAB457CD7}"/>
               </a:ext>
             </a:extLst>
           </p:cNvPr>
@@ -4129,7 +4129,7 @@
           <p:cNvPr id="15" name="">
             <a:extLst xmlns:a="http://schemas.openxmlformats.org/drawingml/2006/main">
               <a:ext uri="{FF2B5EF4-FFF2-40B4-BE49-F238E27FC236}">
-                <a16:creationId xmlns:a16="http://schemas.microsoft.com/office/drawing/2014/main" id="{DD2A295F-A18B-43A9-9A40-5CB228D2A966}"/>
+                <a16:creationId xmlns:a16="http://schemas.microsoft.com/office/drawing/2014/main" id="{8B853629-BC2B-4E0F-904B-65A40E5D7878}"/>
               </a:ext>
             </a:extLst>
           </p:cNvPr>
@@ -4186,7 +4186,7 @@
           <p:cNvPr id="16" name="">
             <a:extLst xmlns:a="http://schemas.openxmlformats.org/drawingml/2006/main">
               <a:ext uri="{FF2B5EF4-FFF2-40B4-BE49-F238E27FC236}">
-                <a16:creationId xmlns:a16="http://schemas.microsoft.com/office/drawing/2014/main" id="{3A6AB60A-2B2C-4D49-988F-72C1C5AF0256}"/>
+                <a16:creationId xmlns:a16="http://schemas.microsoft.com/office/drawing/2014/main" id="{24944BF6-450E-4702-9B06-948190409083}"/>
               </a:ext>
             </a:extLst>
           </p:cNvPr>
@@ -4266,7 +4266,7 @@
           <p:cNvPr id="17" name="">
             <a:extLst xmlns:a="http://schemas.openxmlformats.org/drawingml/2006/main">
               <a:ext uri="{FF2B5EF4-FFF2-40B4-BE49-F238E27FC236}">
-                <a16:creationId xmlns:a16="http://schemas.microsoft.com/office/drawing/2014/main" id="{1767573B-AF12-45E1-AA69-17765CA1CFCD}"/>
+                <a16:creationId xmlns:a16="http://schemas.microsoft.com/office/drawing/2014/main" id="{BFBC3AC9-5A88-4AEE-978B-3B7D7C5FCFB0}"/>
               </a:ext>
             </a:extLst>
           </p:cNvPr>
@@ -4323,7 +4323,7 @@
           <p:cNvPr id="18" name="">
             <a:extLst xmlns:a="http://schemas.openxmlformats.org/drawingml/2006/main">
               <a:ext uri="{FF2B5EF4-FFF2-40B4-BE49-F238E27FC236}">
-                <a16:creationId xmlns:a16="http://schemas.microsoft.com/office/drawing/2014/main" id="{D65F959E-8E97-40E5-B8D5-C34EF67FF082}"/>
+                <a16:creationId xmlns:a16="http://schemas.microsoft.com/office/drawing/2014/main" id="{F75EA178-6F5F-4AC8-8D99-33C690715D24}"/>
               </a:ext>
             </a:extLst>
           </p:cNvPr>
@@ -4353,7 +4353,7 @@
           <p:cNvPr id="19" name="">
             <a:extLst xmlns:a="http://schemas.openxmlformats.org/drawingml/2006/main">
               <a:ext uri="{FF2B5EF4-FFF2-40B4-BE49-F238E27FC236}">
-                <a16:creationId xmlns:a16="http://schemas.microsoft.com/office/drawing/2014/main" id="{3504B0BF-C867-49D5-B6F3-6B534C16442A}"/>
+                <a16:creationId xmlns:a16="http://schemas.microsoft.com/office/drawing/2014/main" id="{48BFF161-FA45-4702-B65E-E8DCE9DBE01A}"/>
               </a:ext>
             </a:extLst>
           </p:cNvPr>
@@ -4410,7 +4410,7 @@
           <p:cNvPr id="20" name="">
             <a:extLst xmlns:a="http://schemas.openxmlformats.org/drawingml/2006/main">
               <a:ext uri="{FF2B5EF4-FFF2-40B4-BE49-F238E27FC236}">
-                <a16:creationId xmlns:a16="http://schemas.microsoft.com/office/drawing/2014/main" id="{20B66C2C-070F-4775-9872-55B21E0A020B}"/>
+                <a16:creationId xmlns:a16="http://schemas.microsoft.com/office/drawing/2014/main" id="{7A3FF044-1FFD-4A6F-8D6D-CD501E951CEC}"/>
               </a:ext>
             </a:extLst>
           </p:cNvPr>
@@ -4488,7 +4488,7 @@
     </p:spTree>
     <p:extLst>
       <p:ext uri="{BB962C8B-B14F-4D97-AF65-F5344CB8AC3E}">
-        <p14:creationId xmlns:p14="http://schemas.microsoft.com/office/powerpoint/2010/main" val="797310768"/>
+        <p14:creationId xmlns:p14="http://schemas.microsoft.com/office/powerpoint/2010/main" val="1627413958"/>
       </p:ext>
     </p:extLst>
   </p:cSld>
@@ -4519,7 +4519,7 @@
           <p:cNvPr id="6" name="">
             <a:extLst xmlns:a="http://schemas.openxmlformats.org/drawingml/2006/main">
               <a:ext uri="{FF2B5EF4-FFF2-40B4-BE49-F238E27FC236}">
-                <a16:creationId xmlns:a16="http://schemas.microsoft.com/office/drawing/2014/main" id="{82BADFBF-0595-4A3E-BEBE-CF0DAA0F84D0}"/>
+                <a16:creationId xmlns:a16="http://schemas.microsoft.com/office/drawing/2014/main" id="{D43F4E5E-5C34-4D30-8A3B-8CA245ED22AB}"/>
               </a:ext>
             </a:extLst>
           </p:cNvPr>
@@ -4576,7 +4576,7 @@
           <p:cNvPr id="2" name="">
             <a:extLst xmlns:a="http://schemas.openxmlformats.org/drawingml/2006/main">
               <a:ext uri="{FF2B5EF4-FFF2-40B4-BE49-F238E27FC236}">
-                <a16:creationId xmlns:a16="http://schemas.microsoft.com/office/drawing/2014/main" id="{80D777A0-B18D-4BAE-90B9-6E0F8BB42411}"/>
+                <a16:creationId xmlns:a16="http://schemas.microsoft.com/office/drawing/2014/main" id="{0D0ECE03-E9AA-41B0-8827-A2AAC32057A6}"/>
               </a:ext>
             </a:extLst>
           </p:cNvPr>
@@ -4633,7 +4633,7 @@
           <p:cNvPr id="3" name="">
             <a:extLst xmlns:a="http://schemas.openxmlformats.org/drawingml/2006/main">
               <a:ext uri="{FF2B5EF4-FFF2-40B4-BE49-F238E27FC236}">
-                <a16:creationId xmlns:a16="http://schemas.microsoft.com/office/drawing/2014/main" id="{F34F475E-54F1-4EBB-ABA5-BAFE39B48144}"/>
+                <a16:creationId xmlns:a16="http://schemas.microsoft.com/office/drawing/2014/main" id="{822A3252-CBD4-4C5A-8B18-6B3DBA4BF029}"/>
               </a:ext>
             </a:extLst>
           </p:cNvPr>
@@ -4962,7 +4962,7 @@
           <p:cNvPr id="5" name="">
             <a:extLst xmlns:a="http://schemas.openxmlformats.org/drawingml/2006/main">
               <a:ext uri="{FF2B5EF4-FFF2-40B4-BE49-F238E27FC236}">
-                <a16:creationId xmlns:a16="http://schemas.microsoft.com/office/drawing/2014/main" id="{3623B985-3B70-4D41-B504-0A0F5D9A50B1}"/>
+                <a16:creationId xmlns:a16="http://schemas.microsoft.com/office/drawing/2014/main" id="{8E4B25FE-B258-4A7C-B45E-C5B1F2CA0765}"/>
               </a:ext>
             </a:extLst>
           </p:cNvPr>
@@ -5040,7 +5040,7 @@
     </p:spTree>
     <p:extLst>
       <p:ext uri="{BB962C8B-B14F-4D97-AF65-F5344CB8AC3E}">
-        <p14:creationId xmlns:p14="http://schemas.microsoft.com/office/powerpoint/2010/main" val="1941566857"/>
+        <p14:creationId xmlns:p14="http://schemas.microsoft.com/office/powerpoint/2010/main" val="200304635"/>
       </p:ext>
     </p:extLst>
   </p:cSld>
@@ -5071,7 +5071,7 @@
           <p:cNvPr id="11" name="">
             <a:extLst xmlns:a="http://schemas.openxmlformats.org/drawingml/2006/main">
               <a:ext uri="{FF2B5EF4-FFF2-40B4-BE49-F238E27FC236}">
-                <a16:creationId xmlns:a16="http://schemas.microsoft.com/office/drawing/2014/main" id="{8BBBE7E7-9FD3-4ADE-B8E6-F396C9B7772D}"/>
+                <a16:creationId xmlns:a16="http://schemas.microsoft.com/office/drawing/2014/main" id="{1E07CDB4-F9D3-4A79-A82F-652DAE70673D}"/>
               </a:ext>
             </a:extLst>
           </p:cNvPr>
@@ -5128,7 +5128,7 @@
           <p:cNvPr id="2" name="">
             <a:extLst xmlns:a="http://schemas.openxmlformats.org/drawingml/2006/main">
               <a:ext uri="{FF2B5EF4-FFF2-40B4-BE49-F238E27FC236}">
-                <a16:creationId xmlns:a16="http://schemas.microsoft.com/office/drawing/2014/main" id="{FB6042F5-E044-4C49-B705-A11B01A192F6}"/>
+                <a16:creationId xmlns:a16="http://schemas.microsoft.com/office/drawing/2014/main" id="{AA40DD68-B37D-45FE-9D6D-9FAC5E10F7E2}"/>
               </a:ext>
             </a:extLst>
           </p:cNvPr>
@@ -5185,7 +5185,7 @@
           <p:cNvPr id="3" name="">
             <a:extLst xmlns:a="http://schemas.openxmlformats.org/drawingml/2006/main">
               <a:ext uri="{FF2B5EF4-FFF2-40B4-BE49-F238E27FC236}">
-                <a16:creationId xmlns:a16="http://schemas.microsoft.com/office/drawing/2014/main" id="{917AC362-D8F9-4166-81CA-406E689F7608}"/>
+                <a16:creationId xmlns:a16="http://schemas.microsoft.com/office/drawing/2014/main" id="{E97BF92D-6C6D-4284-9CDA-BB9F05C987F3}"/>
               </a:ext>
             </a:extLst>
           </p:cNvPr>
@@ -5242,7 +5242,7 @@
           <p:cNvPr id="4" name="">
             <a:extLst xmlns:a="http://schemas.openxmlformats.org/drawingml/2006/main">
               <a:ext uri="{FF2B5EF4-FFF2-40B4-BE49-F238E27FC236}">
-                <a16:creationId xmlns:a16="http://schemas.microsoft.com/office/drawing/2014/main" id="{EC897F21-C572-4463-B00B-1D1A0A7EDCD5}"/>
+                <a16:creationId xmlns:a16="http://schemas.microsoft.com/office/drawing/2014/main" id="{2848D30D-D666-40E9-8250-D721499EF904}"/>
               </a:ext>
             </a:extLst>
           </p:cNvPr>
@@ -5299,7 +5299,7 @@
           <p:cNvPr id="5" name="">
             <a:extLst xmlns:a="http://schemas.openxmlformats.org/drawingml/2006/main">
               <a:ext uri="{FF2B5EF4-FFF2-40B4-BE49-F238E27FC236}">
-                <a16:creationId xmlns:a16="http://schemas.microsoft.com/office/drawing/2014/main" id="{44F5BB5B-7148-42F1-AFC0-7B491EE96E49}"/>
+                <a16:creationId xmlns:a16="http://schemas.microsoft.com/office/drawing/2014/main" id="{9D929EC8-D1A6-4699-9A1B-DAC8A76EBE9D}"/>
               </a:ext>
             </a:extLst>
           </p:cNvPr>
@@ -5356,7 +5356,7 @@
           <p:cNvPr id="6" name="">
             <a:extLst xmlns:a="http://schemas.openxmlformats.org/drawingml/2006/main">
               <a:ext uri="{FF2B5EF4-FFF2-40B4-BE49-F238E27FC236}">
-                <a16:creationId xmlns:a16="http://schemas.microsoft.com/office/drawing/2014/main" id="{1C013845-A27C-41BB-9712-7A959B03BB8D}"/>
+                <a16:creationId xmlns:a16="http://schemas.microsoft.com/office/drawing/2014/main" id="{7FBAA392-80CC-4DF1-90A9-D1ADB9C1BF30}"/>
               </a:ext>
             </a:extLst>
           </p:cNvPr>
@@ -5413,7 +5413,7 @@
           <p:cNvPr id="7" name="">
             <a:extLst xmlns:a="http://schemas.openxmlformats.org/drawingml/2006/main">
               <a:ext uri="{FF2B5EF4-FFF2-40B4-BE49-F238E27FC236}">
-                <a16:creationId xmlns:a16="http://schemas.microsoft.com/office/drawing/2014/main" id="{22BF40EE-9280-4947-83FE-4CC104A731AD}"/>
+                <a16:creationId xmlns:a16="http://schemas.microsoft.com/office/drawing/2014/main" id="{B9485832-E3ED-44E2-86C7-2E135FEDD3CC}"/>
               </a:ext>
             </a:extLst>
           </p:cNvPr>
@@ -5470,7 +5470,7 @@
           <p:cNvPr id="8" name="">
             <a:extLst xmlns:a="http://schemas.openxmlformats.org/drawingml/2006/main">
               <a:ext uri="{FF2B5EF4-FFF2-40B4-BE49-F238E27FC236}">
-                <a16:creationId xmlns:a16="http://schemas.microsoft.com/office/drawing/2014/main" id="{65BC9FA4-F16B-4211-99F1-4275FB191EE3}"/>
+                <a16:creationId xmlns:a16="http://schemas.microsoft.com/office/drawing/2014/main" id="{6E2D8709-DF89-4D58-83DF-616218C91AA2}"/>
               </a:ext>
             </a:extLst>
           </p:cNvPr>
@@ -5527,7 +5527,7 @@
           <p:cNvPr id="9" name="">
             <a:extLst xmlns:a="http://schemas.openxmlformats.org/drawingml/2006/main">
               <a:ext uri="{FF2B5EF4-FFF2-40B4-BE49-F238E27FC236}">
-                <a16:creationId xmlns:a16="http://schemas.microsoft.com/office/drawing/2014/main" id="{A2B54FDB-D35C-4E8E-9421-61F19B460B85}"/>
+                <a16:creationId xmlns:a16="http://schemas.microsoft.com/office/drawing/2014/main" id="{9A716A61-4181-428E-A912-6530E752E971}"/>
               </a:ext>
             </a:extLst>
           </p:cNvPr>
@@ -5584,7 +5584,7 @@
           <p:cNvPr id="10" name="">
             <a:extLst xmlns:a="http://schemas.openxmlformats.org/drawingml/2006/main">
               <a:ext uri="{FF2B5EF4-FFF2-40B4-BE49-F238E27FC236}">
-                <a16:creationId xmlns:a16="http://schemas.microsoft.com/office/drawing/2014/main" id="{B8F0CB99-8C12-4613-A364-AAAF7FCEF694}"/>
+                <a16:creationId xmlns:a16="http://schemas.microsoft.com/office/drawing/2014/main" id="{08A4ED91-9EE2-4731-A9F7-9DF04B164108}"/>
               </a:ext>
             </a:extLst>
           </p:cNvPr>
@@ -5662,7 +5662,7 @@
     </p:spTree>
     <p:extLst>
       <p:ext uri="{BB962C8B-B14F-4D97-AF65-F5344CB8AC3E}">
-        <p14:creationId xmlns:p14="http://schemas.microsoft.com/office/powerpoint/2010/main" val="789274086"/>
+        <p14:creationId xmlns:p14="http://schemas.microsoft.com/office/powerpoint/2010/main" val="2104076846"/>
       </p:ext>
     </p:extLst>
   </p:cSld>
@@ -5693,7 +5693,7 @@
           <p:cNvPr id="10" name="">
             <a:extLst xmlns:a="http://schemas.openxmlformats.org/drawingml/2006/main">
               <a:ext uri="{FF2B5EF4-FFF2-40B4-BE49-F238E27FC236}">
-                <a16:creationId xmlns:a16="http://schemas.microsoft.com/office/drawing/2014/main" id="{2CDEF396-67A4-417C-A3E4-045C469125CC}"/>
+                <a16:creationId xmlns:a16="http://schemas.microsoft.com/office/drawing/2014/main" id="{4303013F-4427-4022-83D6-AC414BFFD963}"/>
               </a:ext>
             </a:extLst>
           </p:cNvPr>
@@ -5750,7 +5750,7 @@
           <p:cNvPr id="2" name="">
             <a:extLst xmlns:a="http://schemas.openxmlformats.org/drawingml/2006/main">
               <a:ext uri="{FF2B5EF4-FFF2-40B4-BE49-F238E27FC236}">
-                <a16:creationId xmlns:a16="http://schemas.microsoft.com/office/drawing/2014/main" id="{31BFC99D-0317-4329-9AC9-37C732E7EB0F}"/>
+                <a16:creationId xmlns:a16="http://schemas.microsoft.com/office/drawing/2014/main" id="{674DDA8F-83A1-43B3-A0C5-8DCE6C8F706C}"/>
               </a:ext>
             </a:extLst>
           </p:cNvPr>
@@ -5807,7 +5807,7 @@
           <p:cNvPr id="3" name="">
             <a:extLst xmlns:a="http://schemas.openxmlformats.org/drawingml/2006/main">
               <a:ext uri="{FF2B5EF4-FFF2-40B4-BE49-F238E27FC236}">
-                <a16:creationId xmlns:a16="http://schemas.microsoft.com/office/drawing/2014/main" id="{541DDA75-DA7C-4F94-ACF4-EE38F9810C3A}"/>
+                <a16:creationId xmlns:a16="http://schemas.microsoft.com/office/drawing/2014/main" id="{4F9BDEF0-71C9-412F-AF92-0A4962AA94FB}"/>
               </a:ext>
             </a:extLst>
           </p:cNvPr>
@@ -5864,7 +5864,7 @@
           <p:cNvPr id="4" name="">
             <a:extLst xmlns:a="http://schemas.openxmlformats.org/drawingml/2006/main">
               <a:ext uri="{FF2B5EF4-FFF2-40B4-BE49-F238E27FC236}">
-                <a16:creationId xmlns:a16="http://schemas.microsoft.com/office/drawing/2014/main" id="{64D8E3E8-96DD-480D-ADA3-D243745519B6}"/>
+                <a16:creationId xmlns:a16="http://schemas.microsoft.com/office/drawing/2014/main" id="{4E4313DB-712A-40F1-A5B6-4770E681B88A}"/>
               </a:ext>
             </a:extLst>
           </p:cNvPr>
@@ -5921,7 +5921,7 @@
           <p:cNvPr id="5" name="">
             <a:extLst xmlns:a="http://schemas.openxmlformats.org/drawingml/2006/main">
               <a:ext uri="{FF2B5EF4-FFF2-40B4-BE49-F238E27FC236}">
-                <a16:creationId xmlns:a16="http://schemas.microsoft.com/office/drawing/2014/main" id="{756B0C1A-64E9-4941-AF72-8225D27FB9D9}"/>
+                <a16:creationId xmlns:a16="http://schemas.microsoft.com/office/drawing/2014/main" id="{80495C64-BFA2-4CD8-9212-B798DE3C5BB6}"/>
               </a:ext>
             </a:extLst>
           </p:cNvPr>
@@ -5999,7 +5999,7 @@
                 <a:ea typeface="DM Sans"/>
                 <a:cs typeface="DM Sans"/>
               </a:rPr>
-              <a:t>Firebase account lifecycle</a:t>
+              <a:t>154 unit + 30 browser tests</a:t>
             </a:r>
           </a:p>
           <a:p xmlns:a="http://schemas.openxmlformats.org/drawingml/2006/main">
@@ -6026,7 +6026,7 @@
                 <a:ea typeface="DM Sans"/>
                 <a:cs typeface="DM Sans"/>
               </a:rPr>
-              <a:t>101 unit + 30 browser tests</a:t>
+              <a:t>Native Test Store flows verified</a:t>
             </a:r>
           </a:p>
           <a:p xmlns:a="http://schemas.openxmlformats.org/drawingml/2006/main">
@@ -6053,7 +6053,7 @@
                 <a:ea typeface="DM Sans"/>
                 <a:cs typeface="DM Sans"/>
               </a:rPr>
-              <a:t>Local projects + portable backups</a:t>
+              <a:t>Live coordinated account deletion</a:t>
             </a:r>
           </a:p>
         </p:txBody>
@@ -6063,7 +6063,7 @@
           <p:cNvPr id="6" name="">
             <a:extLst xmlns:a="http://schemas.openxmlformats.org/drawingml/2006/main">
               <a:ext uri="{FF2B5EF4-FFF2-40B4-BE49-F238E27FC236}">
-                <a16:creationId xmlns:a16="http://schemas.microsoft.com/office/drawing/2014/main" id="{D9B72EDF-2572-460B-BC35-00803CD45BC8}"/>
+                <a16:creationId xmlns:a16="http://schemas.microsoft.com/office/drawing/2014/main" id="{9007406E-AD78-45BF-A433-4ED0072823FA}"/>
               </a:ext>
             </a:extLst>
           </p:cNvPr>
@@ -6120,7 +6120,7 @@
           <p:cNvPr id="7" name="">
             <a:extLst xmlns:a="http://schemas.openxmlformats.org/drawingml/2006/main">
               <a:ext uri="{FF2B5EF4-FFF2-40B4-BE49-F238E27FC236}">
-                <a16:creationId xmlns:a16="http://schemas.microsoft.com/office/drawing/2014/main" id="{DC7BC673-AEB8-4C39-B21E-9661BA706EE5}"/>
+                <a16:creationId xmlns:a16="http://schemas.microsoft.com/office/drawing/2014/main" id="{F54335EF-061F-40A8-A378-2597F035B4F5}"/>
               </a:ext>
             </a:extLst>
           </p:cNvPr>
@@ -6171,7 +6171,7 @@
                 <a:ea typeface="DM Sans"/>
                 <a:cs typeface="DM Sans"/>
               </a:rPr>
-              <a:t>Live RevenueCat purchases</a:t>
+              <a:t>Samsung corporate seller approval</a:t>
             </a:r>
           </a:p>
           <a:p xmlns:a="http://schemas.openxmlformats.org/drawingml/2006/main">
@@ -6198,7 +6198,7 @@
                 <a:ea typeface="DM Sans"/>
                 <a:cs typeface="DM Sans"/>
               </a:rPr>
-              <a:t>Purchase-data deletion backend</a:t>
+              <a:t>Physical store purchase testing</a:t>
             </a:r>
           </a:p>
           <a:p xmlns:a="http://schemas.openxmlformats.org/drawingml/2006/main">
@@ -6225,7 +6225,7 @@
                 <a:ea typeface="DM Sans"/>
                 <a:cs typeface="DM Sans"/>
               </a:rPr>
-              <a:t>Physical Galaxy verification</a:t>
+              <a:t>Production signing + store approval</a:t>
             </a:r>
           </a:p>
           <a:p xmlns:a="http://schemas.openxmlformats.org/drawingml/2006/main">
@@ -6252,7 +6252,7 @@
                 <a:ea typeface="DM Sans"/>
                 <a:cs typeface="DM Sans"/>
               </a:rPr>
-              <a:t>Signed release + store approval</a:t>
+              <a:t>Compiled iOS release binary</a:t>
             </a:r>
           </a:p>
         </p:txBody>
@@ -6262,7 +6262,7 @@
           <p:cNvPr id="8" name="">
             <a:extLst xmlns:a="http://schemas.openxmlformats.org/drawingml/2006/main">
               <a:ext uri="{FF2B5EF4-FFF2-40B4-BE49-F238E27FC236}">
-                <a16:creationId xmlns:a16="http://schemas.microsoft.com/office/drawing/2014/main" id="{837BCCEC-0272-486C-BFBB-67A17E397590}"/>
+                <a16:creationId xmlns:a16="http://schemas.microsoft.com/office/drawing/2014/main" id="{B682C256-D41F-45E7-9C9C-F9711B44720B}"/>
               </a:ext>
             </a:extLst>
           </p:cNvPr>
@@ -6319,7 +6319,7 @@
           <p:cNvPr id="9" name="">
             <a:extLst xmlns:a="http://schemas.openxmlformats.org/drawingml/2006/main">
               <a:ext uri="{FF2B5EF4-FFF2-40B4-BE49-F238E27FC236}">
-                <a16:creationId xmlns:a16="http://schemas.microsoft.com/office/drawing/2014/main" id="{55668DF2-4B06-44E6-88C3-B5C9CD7008CA}"/>
+                <a16:creationId xmlns:a16="http://schemas.microsoft.com/office/drawing/2014/main" id="{7188C909-16B2-4C12-A780-69247C465447}"/>
               </a:ext>
             </a:extLst>
           </p:cNvPr>
@@ -6374,7 +6374,7 @@
     </p:spTree>
     <p:extLst>
       <p:ext uri="{BB962C8B-B14F-4D97-AF65-F5344CB8AC3E}">
-        <p14:creationId xmlns:p14="http://schemas.microsoft.com/office/powerpoint/2010/main" val="1739957109"/>
+        <p14:creationId xmlns:p14="http://schemas.microsoft.com/office/powerpoint/2010/main" val="1846766384"/>
       </p:ext>
     </p:extLst>
   </p:cSld>

</xml_diff>